<commit_message>
Fix Grad-CAM for Keras 3 transfer models; add real Grad-CAM heatmap + classification report slide to presentation
grad_cam() rebuilt: bridge model on base input + copied-weight tail classifier + two-tape chain rule (avoids Keras 3.15 'layer never called' / nested get_layer failures, gradient=None). make_gradcam.py produces results/gradcam_example.jpg. Presentation now 20 slides: Grad-CAM slide shows the real heatmap; new slide adds the per-class classification report table (88.3% acc, 3,345 val images).
</commit_message>
<xml_diff>
--- a/Plant_Leaf_Disease_Detection_IVACIA3.pptx
+++ b/Plant_Leaf_Disease_Detection_IVACIA3.pptx
@@ -24,6 +24,7 @@
     <p:sldId id="272" r:id="rId23"/>
     <p:sldId id="273" r:id="rId24"/>
     <p:sldId id="274" r:id="rId25"/>
+    <p:sldId id="275" r:id="rId26"/>
   </p:sldIdLst>
   <p:sldSz cx="12191695" cy="6858000" type="screen4x3"/>
   <p:notesSz cx="6858000" cy="9144000"/>
@@ -3841,8 +3842,8 @@
         </p:nvSpPr>
         <p:spPr>
           <a:xfrm>
-            <a:off x="822960" y="1463040"/>
-            <a:ext cx="10515600" cy="4937760"/>
+            <a:off x="822960" y="1920240"/>
+            <a:ext cx="10515600" cy="2103120"/>
           </a:xfrm>
           <a:prstGeom prst="rect">
             <a:avLst/>
@@ -3857,9 +3858,9 @@
           <a:p>
             <a:pPr>
               <a:spcAft>
-                <a:spcPts val="1000"/>
-              </a:spcAft>
-              <a:defRPr sz="1700">
+                <a:spcPts val="600"/>
+              </a:spcAft>
+              <a:defRPr sz="1600">
                 <a:solidFill>
                   <a:srgbClr val="212121"/>
                 </a:solidFill>
@@ -3873,9 +3874,9 @@
           <a:p>
             <a:pPr>
               <a:spcAft>
-                <a:spcPts val="1000"/>
-              </a:spcAft>
-              <a:defRPr sz="1700">
+                <a:spcPts val="600"/>
+              </a:spcAft>
+              <a:defRPr sz="1600">
                 <a:solidFill>
                   <a:srgbClr val="212121"/>
                 </a:solidFill>
@@ -3889,9 +3890,9 @@
           <a:p>
             <a:pPr>
               <a:spcAft>
-                <a:spcPts val="1000"/>
-              </a:spcAft>
-              <a:defRPr sz="1700">
+                <a:spcPts val="600"/>
+              </a:spcAft>
+              <a:defRPr sz="1600">
                 <a:solidFill>
                   <a:srgbClr val="212121"/>
                 </a:solidFill>
@@ -3905,56 +3906,48 @@
           <a:p>
             <a:pPr>
               <a:spcAft>
-                <a:spcPts val="1000"/>
-              </a:spcAft>
-              <a:defRPr sz="1700">
-                <a:solidFill>
-                  <a:srgbClr val="212121"/>
-                </a:solidFill>
-                <a:latin typeface="Calibri"/>
-              </a:defRPr>
-            </a:pPr>
-            <a:r>
-              <a:t>• For leaf disease: heatmap focuses on lesion/spots instead of background.</a:t>
-            </a:r>
-          </a:p>
-          <a:p>
-            <a:pPr>
-              <a:spcAft>
-                <a:spcPts val="1000"/>
-              </a:spcAft>
-              <a:defRPr sz="1700">
-                <a:solidFill>
-                  <a:srgbClr val="212121"/>
-                </a:solidFill>
-                <a:latin typeface="Calibri"/>
-              </a:defRPr>
-            </a:pPr>
-            <a:r>
-              <a:t>• Builds trust for agronomists and helps debug misclassifications.</a:t>
-            </a:r>
-          </a:p>
-          <a:p>
-            <a:pPr>
-              <a:spcAft>
-                <a:spcPts val="1000"/>
-              </a:spcAft>
-              <a:defRPr sz="1700">
-                <a:solidFill>
-                  <a:srgbClr val="212121"/>
-                </a:solidFill>
-                <a:latin typeface="Calibri"/>
-              </a:defRPr>
-            </a:pPr>
-            <a:r>
-              <a:t>• Implemented in grad_cam() using a functional sub-model + GradientTape (Keras 3 compatible).</a:t>
-            </a:r>
-          </a:p>
-        </p:txBody>
-      </p:sp>
-      <p:sp>
-        <p:nvSpPr>
-          <p:cNvPr id="4" name="TextBox 3"/>
+                <a:spcPts val="600"/>
+              </a:spcAft>
+              <a:defRPr sz="1600">
+                <a:solidFill>
+                  <a:srgbClr val="212121"/>
+                </a:solidFill>
+                <a:latin typeface="Calibri"/>
+              </a:defRPr>
+            </a:pPr>
+            <a:r>
+              <a:t>• Implemented in grad_cam() (Keras 3 compatible, two-tape chain rule).</a:t>
+            </a:r>
+          </a:p>
+        </p:txBody>
+      </p:sp>
+      <p:pic>
+        <p:nvPicPr>
+          <p:cNvPr id="4" name="Picture 3" descr="gradcam_example.jpg"/>
+          <p:cNvPicPr>
+            <a:picLocks noChangeAspect="1"/>
+          </p:cNvPicPr>
+          <p:nvPr/>
+        </p:nvPicPr>
+        <p:blipFill>
+          <a:blip r:embed="rId2"/>
+          <a:stretch>
+            <a:fillRect/>
+          </a:stretch>
+        </p:blipFill>
+        <p:spPr>
+          <a:xfrm>
+            <a:off x="2011680" y="3063240"/>
+            <a:ext cx="5649711" cy="3063240"/>
+          </a:xfrm>
+          <a:prstGeom prst="rect">
+            <a:avLst/>
+          </a:prstGeom>
+        </p:spPr>
+      </p:pic>
+      <p:sp>
+        <p:nvSpPr>
+          <p:cNvPr id="5" name="TextBox 4"/>
           <p:cNvSpPr txBox="1"/>
           <p:nvPr/>
         </p:nvSpPr>
@@ -4062,7 +4055,7 @@
               </a:defRPr>
             </a:pPr>
             <a:r>
-              <a:t>Web Application — real-time prediction (Gradio)</a:t>
+              <a:t>Classification Report (Validation, 7 Classes)</a:t>
             </a:r>
           </a:p>
         </p:txBody>
@@ -4075,8 +4068,8 @@
         </p:nvSpPr>
         <p:spPr>
           <a:xfrm>
-            <a:off x="822960" y="1371600"/>
-            <a:ext cx="10972800" cy="5029200"/>
+            <a:off x="822960" y="1143000"/>
+            <a:ext cx="10515600" cy="457200"/>
           </a:xfrm>
           <a:prstGeom prst="rect">
             <a:avLst/>
@@ -4089,106 +4082,933 @@
           </a:bodyPr>
           <a:lstStyle/>
           <a:p>
-            <a:pPr>
-              <a:spcAft>
-                <a:spcPts val="900"/>
-              </a:spcAft>
-              <a:defRPr sz="1700">
-                <a:solidFill>
-                  <a:srgbClr val="212121"/>
-                </a:solidFill>
-                <a:latin typeface="Calibri"/>
-              </a:defRPr>
-            </a:pPr>
-            <a:r>
-              <a:t>• run_demo.py loads models/…keras + class_names.json and starts a server</a:t>
-            </a:r>
-          </a:p>
-          <a:p>
-            <a:pPr lvl="1">
-              <a:spcAft>
-                <a:spcPts val="900"/>
-              </a:spcAft>
-              <a:defRPr sz="1500">
-                <a:solidFill>
-                  <a:srgbClr val="212121"/>
-                </a:solidFill>
-                <a:latin typeface="Calibri"/>
-              </a:defRPr>
-            </a:pPr>
-            <a:r>
-              <a:t>   – Browser UI at http://127.0.0.1:7860</a:t>
-            </a:r>
-          </a:p>
-          <a:p>
-            <a:pPr lvl="1">
-              <a:spcAft>
-                <a:spcPts val="900"/>
-              </a:spcAft>
-              <a:defRPr sz="1500">
-                <a:solidFill>
-                  <a:srgbClr val="212121"/>
-                </a:solidFill>
-                <a:latin typeface="Calibri"/>
-              </a:defRPr>
-            </a:pPr>
-            <a:r>
-              <a:t>   – Upload a leaf photo → top-5 disease predictions with confidence %</a:t>
-            </a:r>
-          </a:p>
-          <a:p>
-            <a:pPr lvl="1">
-              <a:spcAft>
-                <a:spcPts val="900"/>
-              </a:spcAft>
-              <a:defRPr sz="1500">
-                <a:solidFill>
-                  <a:srgbClr val="212121"/>
-                </a:solidFill>
-                <a:latin typeface="Calibri"/>
-              </a:defRPr>
-            </a:pPr>
-            <a:r>
-              <a:t>   – Handles common image formats; converts RGBA/B&amp;W uploads to RGB</a:t>
-            </a:r>
-          </a:p>
-          <a:p>
-            <a:pPr>
-              <a:spcAft>
-                <a:spcPts val="900"/>
-              </a:spcAft>
-              <a:defRPr sz="1700">
-                <a:solidFill>
-                  <a:srgbClr val="212121"/>
-                </a:solidFill>
-                <a:latin typeface="Calibri"/>
-              </a:defRPr>
-            </a:pPr>
-            <a:r>
-              <a:t>• Verified live: 4/4 validation samples classified correctly via the API</a:t>
-            </a:r>
-          </a:p>
-          <a:p>
-            <a:pPr>
-              <a:spcAft>
-                <a:spcPts val="900"/>
-              </a:spcAft>
-              <a:defRPr sz="1700">
-                <a:solidFill>
-                  <a:srgbClr val="212121"/>
-                </a:solidFill>
-                <a:latin typeface="Calibri"/>
-              </a:defRPr>
-            </a:pPr>
-            <a:r>
-              <a:t>• Earlier upload bug (4-channel images) found and fixed during testing</a:t>
-            </a:r>
-          </a:p>
-        </p:txBody>
-      </p:sp>
-      <p:sp>
-        <p:nvSpPr>
-          <p:cNvPr id="4" name="TextBox 3"/>
+            <a:pPr algn="l">
+              <a:defRPr sz="1400" b="0">
+                <a:solidFill>
+                  <a:srgbClr val="212121"/>
+                </a:solidFill>
+                <a:latin typeface="Calibri"/>
+              </a:defRPr>
+            </a:pPr>
+            <a:r>
+              <a:t>MobileNetV2 transfer model · 3,345 validation images · accuracy 88.3%</a:t>
+            </a:r>
+          </a:p>
+        </p:txBody>
+      </p:sp>
+      <p:graphicFrame>
+        <p:nvGraphicFramePr>
+          <p:cNvPr id="4" name="Table 3"/>
+          <p:cNvGraphicFramePr>
+            <a:graphicFrameLocks noGrp="1"/>
+          </p:cNvGraphicFramePr>
+          <p:nvPr/>
+        </p:nvGraphicFramePr>
+        <p:xfrm>
+          <a:off x="822960" y="1691640"/>
+          <a:ext cx="10515600" cy="3456432"/>
+        </p:xfrm>
+        <a:graphic>
+          <a:graphicData uri="http://schemas.openxmlformats.org/drawingml/2006/table">
+            <a:tbl>
+              <a:tblPr firstRow="1" bandRow="1">
+                <a:tableStyleId>{5C22544A-7EE6-4342-B048-85BDC9FD1C3A}</a:tableStyleId>
+              </a:tblPr>
+              <a:tblGrid>
+                <a:gridCol w="5669280"/>
+                <a:gridCol w="1737360"/>
+                <a:gridCol w="1463040"/>
+                <a:gridCol w="1645920"/>
+              </a:tblGrid>
+              <a:tr h="384048">
+                <a:tc>
+                  <a:txBody>
+                    <a:bodyPr/>
+                    <a:lstStyle/>
+                    <a:p>
+                      <a:pPr algn="l">
+                        <a:defRPr sz="1500" b="1">
+                          <a:solidFill>
+                            <a:srgbClr val="FFFFFF"/>
+                          </a:solidFill>
+                          <a:latin typeface="Calibri"/>
+                        </a:defRPr>
+                      </a:pPr>
+                      <a:r>
+                        <a:t>Class</a:t>
+                      </a:r>
+                    </a:p>
+                  </a:txBody>
+                  <a:tcPr marT="12700" marB="12700">
+                    <a:solidFill>
+                      <a:srgbClr val="2E7D32"/>
+                    </a:solidFill>
+                  </a:tcPr>
+                </a:tc>
+                <a:tc>
+                  <a:txBody>
+                    <a:bodyPr/>
+                    <a:lstStyle/>
+                    <a:p>
+                      <a:pPr algn="ctr">
+                        <a:defRPr sz="1500" b="1">
+                          <a:solidFill>
+                            <a:srgbClr val="FFFFFF"/>
+                          </a:solidFill>
+                          <a:latin typeface="Calibri"/>
+                        </a:defRPr>
+                      </a:pPr>
+                      <a:r>
+                        <a:t>Precision</a:t>
+                      </a:r>
+                    </a:p>
+                  </a:txBody>
+                  <a:tcPr marT="12700" marB="12700">
+                    <a:solidFill>
+                      <a:srgbClr val="2E7D32"/>
+                    </a:solidFill>
+                  </a:tcPr>
+                </a:tc>
+                <a:tc>
+                  <a:txBody>
+                    <a:bodyPr/>
+                    <a:lstStyle/>
+                    <a:p>
+                      <a:pPr algn="ctr">
+                        <a:defRPr sz="1500" b="1">
+                          <a:solidFill>
+                            <a:srgbClr val="FFFFFF"/>
+                          </a:solidFill>
+                          <a:latin typeface="Calibri"/>
+                        </a:defRPr>
+                      </a:pPr>
+                      <a:r>
+                        <a:t>Recall</a:t>
+                      </a:r>
+                    </a:p>
+                  </a:txBody>
+                  <a:tcPr marT="12700" marB="12700">
+                    <a:solidFill>
+                      <a:srgbClr val="2E7D32"/>
+                    </a:solidFill>
+                  </a:tcPr>
+                </a:tc>
+                <a:tc>
+                  <a:txBody>
+                    <a:bodyPr/>
+                    <a:lstStyle/>
+                    <a:p>
+                      <a:pPr algn="ctr">
+                        <a:defRPr sz="1500" b="1">
+                          <a:solidFill>
+                            <a:srgbClr val="FFFFFF"/>
+                          </a:solidFill>
+                          <a:latin typeface="Calibri"/>
+                        </a:defRPr>
+                      </a:pPr>
+                      <a:r>
+                        <a:t>F1-score</a:t>
+                      </a:r>
+                    </a:p>
+                  </a:txBody>
+                  <a:tcPr marT="12700" marB="12700">
+                    <a:solidFill>
+                      <a:srgbClr val="2E7D32"/>
+                    </a:solidFill>
+                  </a:tcPr>
+                </a:tc>
+              </a:tr>
+              <a:tr h="384048">
+                <a:tc>
+                  <a:txBody>
+                    <a:bodyPr/>
+                    <a:lstStyle/>
+                    <a:p>
+                      <a:pPr algn="l">
+                        <a:defRPr sz="1400" b="0">
+                          <a:solidFill>
+                            <a:srgbClr val="212121"/>
+                          </a:solidFill>
+                          <a:latin typeface="Calibri"/>
+                        </a:defRPr>
+                      </a:pPr>
+                      <a:r>
+                        <a:t>Pepper — Bacterial spot</a:t>
+                      </a:r>
+                    </a:p>
+                  </a:txBody>
+                  <a:tcPr marT="12700" marB="12700">
+                    <a:solidFill>
+                      <a:srgbClr val="FBFAF0"/>
+                    </a:solidFill>
+                  </a:tcPr>
+                </a:tc>
+                <a:tc>
+                  <a:txBody>
+                    <a:bodyPr/>
+                    <a:lstStyle/>
+                    <a:p>
+                      <a:pPr algn="ctr">
+                        <a:defRPr sz="1400" b="0">
+                          <a:solidFill>
+                            <a:srgbClr val="212121"/>
+                          </a:solidFill>
+                          <a:latin typeface="Calibri"/>
+                        </a:defRPr>
+                      </a:pPr>
+                      <a:r>
+                        <a:t>0.79</a:t>
+                      </a:r>
+                    </a:p>
+                  </a:txBody>
+                  <a:tcPr marT="12700" marB="12700">
+                    <a:solidFill>
+                      <a:srgbClr val="FBFAF0"/>
+                    </a:solidFill>
+                  </a:tcPr>
+                </a:tc>
+                <a:tc>
+                  <a:txBody>
+                    <a:bodyPr/>
+                    <a:lstStyle/>
+                    <a:p>
+                      <a:pPr algn="ctr">
+                        <a:defRPr sz="1400" b="0">
+                          <a:solidFill>
+                            <a:srgbClr val="212121"/>
+                          </a:solidFill>
+                          <a:latin typeface="Calibri"/>
+                        </a:defRPr>
+                      </a:pPr>
+                      <a:r>
+                        <a:t>0.94</a:t>
+                      </a:r>
+                    </a:p>
+                  </a:txBody>
+                  <a:tcPr marT="12700" marB="12700">
+                    <a:solidFill>
+                      <a:srgbClr val="FBFAF0"/>
+                    </a:solidFill>
+                  </a:tcPr>
+                </a:tc>
+                <a:tc>
+                  <a:txBody>
+                    <a:bodyPr/>
+                    <a:lstStyle/>
+                    <a:p>
+                      <a:pPr algn="ctr">
+                        <a:defRPr sz="1400" b="0">
+                          <a:solidFill>
+                            <a:srgbClr val="212121"/>
+                          </a:solidFill>
+                          <a:latin typeface="Calibri"/>
+                        </a:defRPr>
+                      </a:pPr>
+                      <a:r>
+                        <a:t>0.86</a:t>
+                      </a:r>
+                    </a:p>
+                  </a:txBody>
+                  <a:tcPr marT="12700" marB="12700">
+                    <a:solidFill>
+                      <a:srgbClr val="FBFAF0"/>
+                    </a:solidFill>
+                  </a:tcPr>
+                </a:tc>
+              </a:tr>
+              <a:tr h="384048">
+                <a:tc>
+                  <a:txBody>
+                    <a:bodyPr/>
+                    <a:lstStyle/>
+                    <a:p>
+                      <a:pPr algn="l">
+                        <a:defRPr sz="1400" b="0">
+                          <a:solidFill>
+                            <a:srgbClr val="212121"/>
+                          </a:solidFill>
+                          <a:latin typeface="Calibri"/>
+                        </a:defRPr>
+                      </a:pPr>
+                      <a:r>
+                        <a:t>Pepper — healthy</a:t>
+                      </a:r>
+                    </a:p>
+                  </a:txBody>
+                  <a:tcPr marT="12700" marB="12700">
+                    <a:solidFill>
+                      <a:srgbClr val="A5D6A7"/>
+                    </a:solidFill>
+                  </a:tcPr>
+                </a:tc>
+                <a:tc>
+                  <a:txBody>
+                    <a:bodyPr/>
+                    <a:lstStyle/>
+                    <a:p>
+                      <a:pPr algn="ctr">
+                        <a:defRPr sz="1400" b="0">
+                          <a:solidFill>
+                            <a:srgbClr val="212121"/>
+                          </a:solidFill>
+                          <a:latin typeface="Calibri"/>
+                        </a:defRPr>
+                      </a:pPr>
+                      <a:r>
+                        <a:t>0.91</a:t>
+                      </a:r>
+                    </a:p>
+                  </a:txBody>
+                  <a:tcPr marT="12700" marB="12700">
+                    <a:solidFill>
+                      <a:srgbClr val="A5D6A7"/>
+                    </a:solidFill>
+                  </a:tcPr>
+                </a:tc>
+                <a:tc>
+                  <a:txBody>
+                    <a:bodyPr/>
+                    <a:lstStyle/>
+                    <a:p>
+                      <a:pPr algn="ctr">
+                        <a:defRPr sz="1400" b="0">
+                          <a:solidFill>
+                            <a:srgbClr val="212121"/>
+                          </a:solidFill>
+                          <a:latin typeface="Calibri"/>
+                        </a:defRPr>
+                      </a:pPr>
+                      <a:r>
+                        <a:t>0.84</a:t>
+                      </a:r>
+                    </a:p>
+                  </a:txBody>
+                  <a:tcPr marT="12700" marB="12700">
+                    <a:solidFill>
+                      <a:srgbClr val="A5D6A7"/>
+                    </a:solidFill>
+                  </a:tcPr>
+                </a:tc>
+                <a:tc>
+                  <a:txBody>
+                    <a:bodyPr/>
+                    <a:lstStyle/>
+                    <a:p>
+                      <a:pPr algn="ctr">
+                        <a:defRPr sz="1400" b="0">
+                          <a:solidFill>
+                            <a:srgbClr val="212121"/>
+                          </a:solidFill>
+                          <a:latin typeface="Calibri"/>
+                        </a:defRPr>
+                      </a:pPr>
+                      <a:r>
+                        <a:t>0.88</a:t>
+                      </a:r>
+                    </a:p>
+                  </a:txBody>
+                  <a:tcPr marT="12700" marB="12700">
+                    <a:solidFill>
+                      <a:srgbClr val="A5D6A7"/>
+                    </a:solidFill>
+                  </a:tcPr>
+                </a:tc>
+              </a:tr>
+              <a:tr h="384048">
+                <a:tc>
+                  <a:txBody>
+                    <a:bodyPr/>
+                    <a:lstStyle/>
+                    <a:p>
+                      <a:pPr algn="l">
+                        <a:defRPr sz="1400" b="0">
+                          <a:solidFill>
+                            <a:srgbClr val="212121"/>
+                          </a:solidFill>
+                          <a:latin typeface="Calibri"/>
+                        </a:defRPr>
+                      </a:pPr>
+                      <a:r>
+                        <a:t>Potato — Early blight</a:t>
+                      </a:r>
+                    </a:p>
+                  </a:txBody>
+                  <a:tcPr marT="12700" marB="12700">
+                    <a:solidFill>
+                      <a:srgbClr val="FBFAF0"/>
+                    </a:solidFill>
+                  </a:tcPr>
+                </a:tc>
+                <a:tc>
+                  <a:txBody>
+                    <a:bodyPr/>
+                    <a:lstStyle/>
+                    <a:p>
+                      <a:pPr algn="ctr">
+                        <a:defRPr sz="1400" b="0">
+                          <a:solidFill>
+                            <a:srgbClr val="212121"/>
+                          </a:solidFill>
+                          <a:latin typeface="Calibri"/>
+                        </a:defRPr>
+                      </a:pPr>
+                      <a:r>
+                        <a:t>0.96</a:t>
+                      </a:r>
+                    </a:p>
+                  </a:txBody>
+                  <a:tcPr marT="12700" marB="12700">
+                    <a:solidFill>
+                      <a:srgbClr val="FBFAF0"/>
+                    </a:solidFill>
+                  </a:tcPr>
+                </a:tc>
+                <a:tc>
+                  <a:txBody>
+                    <a:bodyPr/>
+                    <a:lstStyle/>
+                    <a:p>
+                      <a:pPr algn="ctr">
+                        <a:defRPr sz="1400" b="0">
+                          <a:solidFill>
+                            <a:srgbClr val="212121"/>
+                          </a:solidFill>
+                          <a:latin typeface="Calibri"/>
+                        </a:defRPr>
+                      </a:pPr>
+                      <a:r>
+                        <a:t>0.93</a:t>
+                      </a:r>
+                    </a:p>
+                  </a:txBody>
+                  <a:tcPr marT="12700" marB="12700">
+                    <a:solidFill>
+                      <a:srgbClr val="FBFAF0"/>
+                    </a:solidFill>
+                  </a:tcPr>
+                </a:tc>
+                <a:tc>
+                  <a:txBody>
+                    <a:bodyPr/>
+                    <a:lstStyle/>
+                    <a:p>
+                      <a:pPr algn="ctr">
+                        <a:defRPr sz="1400" b="0">
+                          <a:solidFill>
+                            <a:srgbClr val="212121"/>
+                          </a:solidFill>
+                          <a:latin typeface="Calibri"/>
+                        </a:defRPr>
+                      </a:pPr>
+                      <a:r>
+                        <a:t>0.94</a:t>
+                      </a:r>
+                    </a:p>
+                  </a:txBody>
+                  <a:tcPr marT="12700" marB="12700">
+                    <a:solidFill>
+                      <a:srgbClr val="FBFAF0"/>
+                    </a:solidFill>
+                  </a:tcPr>
+                </a:tc>
+              </a:tr>
+              <a:tr h="384048">
+                <a:tc>
+                  <a:txBody>
+                    <a:bodyPr/>
+                    <a:lstStyle/>
+                    <a:p>
+                      <a:pPr algn="l">
+                        <a:defRPr sz="1400" b="0">
+                          <a:solidFill>
+                            <a:srgbClr val="212121"/>
+                          </a:solidFill>
+                          <a:latin typeface="Calibri"/>
+                        </a:defRPr>
+                      </a:pPr>
+                      <a:r>
+                        <a:t>Potato — Late blight</a:t>
+                      </a:r>
+                    </a:p>
+                  </a:txBody>
+                  <a:tcPr marT="12700" marB="12700">
+                    <a:solidFill>
+                      <a:srgbClr val="A5D6A7"/>
+                    </a:solidFill>
+                  </a:tcPr>
+                </a:tc>
+                <a:tc>
+                  <a:txBody>
+                    <a:bodyPr/>
+                    <a:lstStyle/>
+                    <a:p>
+                      <a:pPr algn="ctr">
+                        <a:defRPr sz="1400" b="0">
+                          <a:solidFill>
+                            <a:srgbClr val="212121"/>
+                          </a:solidFill>
+                          <a:latin typeface="Calibri"/>
+                        </a:defRPr>
+                      </a:pPr>
+                      <a:r>
+                        <a:t>0.91</a:t>
+                      </a:r>
+                    </a:p>
+                  </a:txBody>
+                  <a:tcPr marT="12700" marB="12700">
+                    <a:solidFill>
+                      <a:srgbClr val="A5D6A7"/>
+                    </a:solidFill>
+                  </a:tcPr>
+                </a:tc>
+                <a:tc>
+                  <a:txBody>
+                    <a:bodyPr/>
+                    <a:lstStyle/>
+                    <a:p>
+                      <a:pPr algn="ctr">
+                        <a:defRPr sz="1400" b="0">
+                          <a:solidFill>
+                            <a:srgbClr val="212121"/>
+                          </a:solidFill>
+                          <a:latin typeface="Calibri"/>
+                        </a:defRPr>
+                      </a:pPr>
+                      <a:r>
+                        <a:t>0.81</a:t>
+                      </a:r>
+                    </a:p>
+                  </a:txBody>
+                  <a:tcPr marT="12700" marB="12700">
+                    <a:solidFill>
+                      <a:srgbClr val="A5D6A7"/>
+                    </a:solidFill>
+                  </a:tcPr>
+                </a:tc>
+                <a:tc>
+                  <a:txBody>
+                    <a:bodyPr/>
+                    <a:lstStyle/>
+                    <a:p>
+                      <a:pPr algn="ctr">
+                        <a:defRPr sz="1400" b="0">
+                          <a:solidFill>
+                            <a:srgbClr val="212121"/>
+                          </a:solidFill>
+                          <a:latin typeface="Calibri"/>
+                        </a:defRPr>
+                      </a:pPr>
+                      <a:r>
+                        <a:t>0.85</a:t>
+                      </a:r>
+                    </a:p>
+                  </a:txBody>
+                  <a:tcPr marT="12700" marB="12700">
+                    <a:solidFill>
+                      <a:srgbClr val="A5D6A7"/>
+                    </a:solidFill>
+                  </a:tcPr>
+                </a:tc>
+              </a:tr>
+              <a:tr h="384048">
+                <a:tc>
+                  <a:txBody>
+                    <a:bodyPr/>
+                    <a:lstStyle/>
+                    <a:p>
+                      <a:pPr algn="l">
+                        <a:defRPr sz="1400" b="0">
+                          <a:solidFill>
+                            <a:srgbClr val="212121"/>
+                          </a:solidFill>
+                          <a:latin typeface="Calibri"/>
+                        </a:defRPr>
+                      </a:pPr>
+                      <a:r>
+                        <a:t>Potato — healthy</a:t>
+                      </a:r>
+                    </a:p>
+                  </a:txBody>
+                  <a:tcPr marT="12700" marB="12700">
+                    <a:solidFill>
+                      <a:srgbClr val="FBFAF0"/>
+                    </a:solidFill>
+                  </a:tcPr>
+                </a:tc>
+                <a:tc>
+                  <a:txBody>
+                    <a:bodyPr/>
+                    <a:lstStyle/>
+                    <a:p>
+                      <a:pPr algn="ctr">
+                        <a:defRPr sz="1400" b="0">
+                          <a:solidFill>
+                            <a:srgbClr val="212121"/>
+                          </a:solidFill>
+                          <a:latin typeface="Calibri"/>
+                        </a:defRPr>
+                      </a:pPr>
+                      <a:r>
+                        <a:t>0.87</a:t>
+                      </a:r>
+                    </a:p>
+                  </a:txBody>
+                  <a:tcPr marT="12700" marB="12700">
+                    <a:solidFill>
+                      <a:srgbClr val="FBFAF0"/>
+                    </a:solidFill>
+                  </a:tcPr>
+                </a:tc>
+                <a:tc>
+                  <a:txBody>
+                    <a:bodyPr/>
+                    <a:lstStyle/>
+                    <a:p>
+                      <a:pPr algn="ctr">
+                        <a:defRPr sz="1400" b="0">
+                          <a:solidFill>
+                            <a:srgbClr val="212121"/>
+                          </a:solidFill>
+                          <a:latin typeface="Calibri"/>
+                        </a:defRPr>
+                      </a:pPr>
+                      <a:r>
+                        <a:t>0.93</a:t>
+                      </a:r>
+                    </a:p>
+                  </a:txBody>
+                  <a:tcPr marT="12700" marB="12700">
+                    <a:solidFill>
+                      <a:srgbClr val="FBFAF0"/>
+                    </a:solidFill>
+                  </a:tcPr>
+                </a:tc>
+                <a:tc>
+                  <a:txBody>
+                    <a:bodyPr/>
+                    <a:lstStyle/>
+                    <a:p>
+                      <a:pPr algn="ctr">
+                        <a:defRPr sz="1400" b="0">
+                          <a:solidFill>
+                            <a:srgbClr val="212121"/>
+                          </a:solidFill>
+                          <a:latin typeface="Calibri"/>
+                        </a:defRPr>
+                      </a:pPr>
+                      <a:r>
+                        <a:t>0.9</a:t>
+                      </a:r>
+                    </a:p>
+                  </a:txBody>
+                  <a:tcPr marT="12700" marB="12700">
+                    <a:solidFill>
+                      <a:srgbClr val="FBFAF0"/>
+                    </a:solidFill>
+                  </a:tcPr>
+                </a:tc>
+              </a:tr>
+              <a:tr h="384048">
+                <a:tc>
+                  <a:txBody>
+                    <a:bodyPr/>
+                    <a:lstStyle/>
+                    <a:p>
+                      <a:pPr algn="l">
+                        <a:defRPr sz="1400" b="0">
+                          <a:solidFill>
+                            <a:srgbClr val="212121"/>
+                          </a:solidFill>
+                          <a:latin typeface="Calibri"/>
+                        </a:defRPr>
+                      </a:pPr>
+                      <a:r>
+                        <a:t>Tomato — Late blight</a:t>
+                      </a:r>
+                    </a:p>
+                  </a:txBody>
+                  <a:tcPr marT="12700" marB="12700">
+                    <a:solidFill>
+                      <a:srgbClr val="A5D6A7"/>
+                    </a:solidFill>
+                  </a:tcPr>
+                </a:tc>
+                <a:tc>
+                  <a:txBody>
+                    <a:bodyPr/>
+                    <a:lstStyle/>
+                    <a:p>
+                      <a:pPr algn="ctr">
+                        <a:defRPr sz="1400" b="0">
+                          <a:solidFill>
+                            <a:srgbClr val="212121"/>
+                          </a:solidFill>
+                          <a:latin typeface="Calibri"/>
+                        </a:defRPr>
+                      </a:pPr>
+                      <a:r>
+                        <a:t>0.81</a:t>
+                      </a:r>
+                    </a:p>
+                  </a:txBody>
+                  <a:tcPr marT="12700" marB="12700">
+                    <a:solidFill>
+                      <a:srgbClr val="A5D6A7"/>
+                    </a:solidFill>
+                  </a:tcPr>
+                </a:tc>
+                <a:tc>
+                  <a:txBody>
+                    <a:bodyPr/>
+                    <a:lstStyle/>
+                    <a:p>
+                      <a:pPr algn="ctr">
+                        <a:defRPr sz="1400" b="0">
+                          <a:solidFill>
+                            <a:srgbClr val="212121"/>
+                          </a:solidFill>
+                          <a:latin typeface="Calibri"/>
+                        </a:defRPr>
+                      </a:pPr>
+                      <a:r>
+                        <a:t>0.92</a:t>
+                      </a:r>
+                    </a:p>
+                  </a:txBody>
+                  <a:tcPr marT="12700" marB="12700">
+                    <a:solidFill>
+                      <a:srgbClr val="A5D6A7"/>
+                    </a:solidFill>
+                  </a:tcPr>
+                </a:tc>
+                <a:tc>
+                  <a:txBody>
+                    <a:bodyPr/>
+                    <a:lstStyle/>
+                    <a:p>
+                      <a:pPr algn="ctr">
+                        <a:defRPr sz="1400" b="0">
+                          <a:solidFill>
+                            <a:srgbClr val="212121"/>
+                          </a:solidFill>
+                          <a:latin typeface="Calibri"/>
+                        </a:defRPr>
+                      </a:pPr>
+                      <a:r>
+                        <a:t>0.86</a:t>
+                      </a:r>
+                    </a:p>
+                  </a:txBody>
+                  <a:tcPr marT="12700" marB="12700">
+                    <a:solidFill>
+                      <a:srgbClr val="A5D6A7"/>
+                    </a:solidFill>
+                  </a:tcPr>
+                </a:tc>
+              </a:tr>
+              <a:tr h="384048">
+                <a:tc>
+                  <a:txBody>
+                    <a:bodyPr/>
+                    <a:lstStyle/>
+                    <a:p>
+                      <a:pPr algn="l">
+                        <a:defRPr sz="1400" b="0">
+                          <a:solidFill>
+                            <a:srgbClr val="212121"/>
+                          </a:solidFill>
+                          <a:latin typeface="Calibri"/>
+                        </a:defRPr>
+                      </a:pPr>
+                      <a:r>
+                        <a:t>Tomato — healthy</a:t>
+                      </a:r>
+                    </a:p>
+                  </a:txBody>
+                  <a:tcPr marT="12700" marB="12700">
+                    <a:solidFill>
+                      <a:srgbClr val="FBFAF0"/>
+                    </a:solidFill>
+                  </a:tcPr>
+                </a:tc>
+                <a:tc>
+                  <a:txBody>
+                    <a:bodyPr/>
+                    <a:lstStyle/>
+                    <a:p>
+                      <a:pPr algn="ctr">
+                        <a:defRPr sz="1400" b="0">
+                          <a:solidFill>
+                            <a:srgbClr val="212121"/>
+                          </a:solidFill>
+                          <a:latin typeface="Calibri"/>
+                        </a:defRPr>
+                      </a:pPr>
+                      <a:r>
+                        <a:t>0.98</a:t>
+                      </a:r>
+                    </a:p>
+                  </a:txBody>
+                  <a:tcPr marT="12700" marB="12700">
+                    <a:solidFill>
+                      <a:srgbClr val="FBFAF0"/>
+                    </a:solidFill>
+                  </a:tcPr>
+                </a:tc>
+                <a:tc>
+                  <a:txBody>
+                    <a:bodyPr/>
+                    <a:lstStyle/>
+                    <a:p>
+                      <a:pPr algn="ctr">
+                        <a:defRPr sz="1400" b="0">
+                          <a:solidFill>
+                            <a:srgbClr val="212121"/>
+                          </a:solidFill>
+                          <a:latin typeface="Calibri"/>
+                        </a:defRPr>
+                      </a:pPr>
+                      <a:r>
+                        <a:t>0.83</a:t>
+                      </a:r>
+                    </a:p>
+                  </a:txBody>
+                  <a:tcPr marT="12700" marB="12700">
+                    <a:solidFill>
+                      <a:srgbClr val="FBFAF0"/>
+                    </a:solidFill>
+                  </a:tcPr>
+                </a:tc>
+                <a:tc>
+                  <a:txBody>
+                    <a:bodyPr/>
+                    <a:lstStyle/>
+                    <a:p>
+                      <a:pPr algn="ctr">
+                        <a:defRPr sz="1400" b="0">
+                          <a:solidFill>
+                            <a:srgbClr val="212121"/>
+                          </a:solidFill>
+                          <a:latin typeface="Calibri"/>
+                        </a:defRPr>
+                      </a:pPr>
+                      <a:r>
+                        <a:t>0.9</a:t>
+                      </a:r>
+                    </a:p>
+                  </a:txBody>
+                  <a:tcPr marT="12700" marB="12700">
+                    <a:solidFill>
+                      <a:srgbClr val="FBFAF0"/>
+                    </a:solidFill>
+                  </a:tcPr>
+                </a:tc>
+              </a:tr>
+              <a:tr h="384048">
+                <a:tc>
+                  <a:txBody>
+                    <a:bodyPr/>
+                    <a:lstStyle/>
+                    <a:p>
+                      <a:pPr algn="l">
+                        <a:defRPr sz="1400" b="1">
+                          <a:solidFill>
+                            <a:srgbClr val="212121"/>
+                          </a:solidFill>
+                          <a:latin typeface="Calibri"/>
+                        </a:defRPr>
+                      </a:pPr>
+                      <a:r>
+                        <a:t>macro average</a:t>
+                      </a:r>
+                    </a:p>
+                  </a:txBody>
+                  <a:tcPr marT="12700" marB="12700">
+                    <a:solidFill>
+                      <a:srgbClr val="A5D6A7"/>
+                    </a:solidFill>
+                  </a:tcPr>
+                </a:tc>
+                <a:tc>
+                  <a:txBody>
+                    <a:bodyPr/>
+                    <a:lstStyle/>
+                    <a:p>
+                      <a:pPr algn="ctr">
+                        <a:defRPr sz="1400" b="1">
+                          <a:solidFill>
+                            <a:srgbClr val="212121"/>
+                          </a:solidFill>
+                          <a:latin typeface="Calibri"/>
+                        </a:defRPr>
+                      </a:pPr>
+                      <a:r>
+                        <a:t>0.89</a:t>
+                      </a:r>
+                    </a:p>
+                  </a:txBody>
+                  <a:tcPr marT="12700" marB="12700">
+                    <a:solidFill>
+                      <a:srgbClr val="A5D6A7"/>
+                    </a:solidFill>
+                  </a:tcPr>
+                </a:tc>
+                <a:tc>
+                  <a:txBody>
+                    <a:bodyPr/>
+                    <a:lstStyle/>
+                    <a:p>
+                      <a:pPr algn="ctr">
+                        <a:defRPr sz="1400" b="1">
+                          <a:solidFill>
+                            <a:srgbClr val="212121"/>
+                          </a:solidFill>
+                          <a:latin typeface="Calibri"/>
+                        </a:defRPr>
+                      </a:pPr>
+                      <a:r>
+                        <a:t>0.88</a:t>
+                      </a:r>
+                    </a:p>
+                  </a:txBody>
+                  <a:tcPr marT="12700" marB="12700">
+                    <a:solidFill>
+                      <a:srgbClr val="A5D6A7"/>
+                    </a:solidFill>
+                  </a:tcPr>
+                </a:tc>
+                <a:tc>
+                  <a:txBody>
+                    <a:bodyPr/>
+                    <a:lstStyle/>
+                    <a:p>
+                      <a:pPr algn="ctr">
+                        <a:defRPr sz="1400" b="1">
+                          <a:solidFill>
+                            <a:srgbClr val="212121"/>
+                          </a:solidFill>
+                          <a:latin typeface="Calibri"/>
+                        </a:defRPr>
+                      </a:pPr>
+                      <a:r>
+                        <a:t>0.88</a:t>
+                      </a:r>
+                    </a:p>
+                  </a:txBody>
+                  <a:tcPr marT="12700" marB="12700">
+                    <a:solidFill>
+                      <a:srgbClr val="A5D6A7"/>
+                    </a:solidFill>
+                  </a:tcPr>
+                </a:tc>
+              </a:tr>
+            </a:tbl>
+          </a:graphicData>
+        </a:graphic>
+      </p:graphicFrame>
+      <p:sp>
+        <p:nvSpPr>
+          <p:cNvPr id="5" name="TextBox 4"/>
           <p:cNvSpPr txBox="1"/>
           <p:nvPr/>
         </p:nvSpPr>
@@ -4296,7 +5116,7 @@
               </a:defRPr>
             </a:pPr>
             <a:r>
-              <a:t>Project Files &amp; Structure</a:t>
+              <a:t>Web Application — real-time prediction (Gradio)</a:t>
             </a:r>
           </a:p>
         </p:txBody>
@@ -4325,145 +5145,97 @@
           <a:p>
             <a:pPr>
               <a:spcAft>
-                <a:spcPts val="800"/>
-              </a:spcAft>
-              <a:defRPr sz="1600">
-                <a:solidFill>
-                  <a:srgbClr val="212121"/>
-                </a:solidFill>
-                <a:latin typeface="Calibri"/>
-              </a:defRPr>
-            </a:pPr>
-            <a:r>
-              <a:t>• plant_disease_detection.py — full 38-class pipeline (all models, Grad-CAM, evaluation)</a:t>
+                <a:spcPts val="900"/>
+              </a:spcAft>
+              <a:defRPr sz="1700">
+                <a:solidFill>
+                  <a:srgbClr val="212121"/>
+                </a:solidFill>
+                <a:latin typeface="Calibri"/>
+              </a:defRPr>
+            </a:pPr>
+            <a:r>
+              <a:t>• run_demo.py loads models/…keras + class_names.json and starts a server</a:t>
+            </a:r>
+          </a:p>
+          <a:p>
+            <a:pPr lvl="1">
+              <a:spcAft>
+                <a:spcPts val="900"/>
+              </a:spcAft>
+              <a:defRPr sz="1500">
+                <a:solidFill>
+                  <a:srgbClr val="212121"/>
+                </a:solidFill>
+                <a:latin typeface="Calibri"/>
+              </a:defRPr>
+            </a:pPr>
+            <a:r>
+              <a:t>   – Browser UI at http://127.0.0.1:7860</a:t>
+            </a:r>
+          </a:p>
+          <a:p>
+            <a:pPr lvl="1">
+              <a:spcAft>
+                <a:spcPts val="900"/>
+              </a:spcAft>
+              <a:defRPr sz="1500">
+                <a:solidFill>
+                  <a:srgbClr val="212121"/>
+                </a:solidFill>
+                <a:latin typeface="Calibri"/>
+              </a:defRPr>
+            </a:pPr>
+            <a:r>
+              <a:t>   – Upload a leaf photo → top-5 disease predictions with confidence %</a:t>
+            </a:r>
+          </a:p>
+          <a:p>
+            <a:pPr lvl="1">
+              <a:spcAft>
+                <a:spcPts val="900"/>
+              </a:spcAft>
+              <a:defRPr sz="1500">
+                <a:solidFill>
+                  <a:srgbClr val="212121"/>
+                </a:solidFill>
+                <a:latin typeface="Calibri"/>
+              </a:defRPr>
+            </a:pPr>
+            <a:r>
+              <a:t>   – Handles common image formats; converts RGBA/B&amp;W uploads to RGB</a:t>
             </a:r>
           </a:p>
           <a:p>
             <a:pPr>
               <a:spcAft>
-                <a:spcPts val="800"/>
-              </a:spcAft>
-              <a:defRPr sz="1600">
-                <a:solidFill>
-                  <a:srgbClr val="212121"/>
-                </a:solidFill>
-                <a:latin typeface="Calibri"/>
-              </a:defRPr>
-            </a:pPr>
-            <a:r>
-              <a:t>• plant_disease_detection_quick.py — CPU-friendly 7-class training</a:t>
+                <a:spcPts val="900"/>
+              </a:spcAft>
+              <a:defRPr sz="1700">
+                <a:solidFill>
+                  <a:srgbClr val="212121"/>
+                </a:solidFill>
+                <a:latin typeface="Calibri"/>
+              </a:defRPr>
+            </a:pPr>
+            <a:r>
+              <a:t>• Verified live: 4/4 validation samples classified correctly via the API</a:t>
             </a:r>
           </a:p>
           <a:p>
             <a:pPr>
               <a:spcAft>
-                <a:spcPts val="800"/>
-              </a:spcAft>
-              <a:defRPr sz="1600">
-                <a:solidFill>
-                  <a:srgbClr val="212121"/>
-                </a:solidFill>
-                <a:latin typeface="Calibri"/>
-              </a:defRPr>
-            </a:pPr>
-            <a:r>
-              <a:t>• download_dataset.py — automatic Kaggle download</a:t>
-            </a:r>
-          </a:p>
-          <a:p>
-            <a:pPr>
-              <a:spcAft>
-                <a:spcPts val="800"/>
-              </a:spcAft>
-              <a:defRPr sz="1600">
-                <a:solidFill>
-                  <a:srgbClr val="212121"/>
-                </a:solidFill>
-                <a:latin typeface="Calibri"/>
-              </a:defRPr>
-            </a:pPr>
-            <a:r>
-              <a:t>• run_demo.py — Gradio web application</a:t>
-            </a:r>
-          </a:p>
-          <a:p>
-            <a:pPr>
-              <a:spcAft>
-                <a:spcPts val="800"/>
-              </a:spcAft>
-              <a:defRPr sz="1600">
-                <a:solidFill>
-                  <a:srgbClr val="212121"/>
-                </a:solidFill>
-                <a:latin typeface="Calibri"/>
-              </a:defRPr>
-            </a:pPr>
-            <a:r>
-              <a:t>• requirements.txt — dependencies</a:t>
-            </a:r>
-          </a:p>
-          <a:p>
-            <a:pPr>
-              <a:spcAft>
-                <a:spcPts val="800"/>
-              </a:spcAft>
-              <a:defRPr sz="1600">
-                <a:solidFill>
-                  <a:srgbClr val="212121"/>
-                </a:solidFill>
-                <a:latin typeface="Calibri"/>
-              </a:defRPr>
-            </a:pPr>
-            <a:r>
-              <a:t>• README.md · WORKING_PROTOCOL.md — documentation</a:t>
-            </a:r>
-          </a:p>
-          <a:p>
-            <a:pPr>
-              <a:spcAft>
-                <a:spcPts val="800"/>
-              </a:spcAft>
-              <a:defRPr sz="1600">
-                <a:solidFill>
-                  <a:srgbClr val="212121"/>
-                </a:solidFill>
-                <a:latin typeface="Calibri"/>
-              </a:defRPr>
-            </a:pPr>
-            <a:r>
-              <a:t>• results/ — training curve, confusion matrix images</a:t>
-            </a:r>
-          </a:p>
-          <a:p>
-            <a:pPr>
-              <a:spcAft>
-                <a:spcPts val="800"/>
-              </a:spcAft>
-              <a:defRPr sz="1600">
-                <a:solidFill>
-                  <a:srgbClr val="212121"/>
-                </a:solidFill>
-                <a:latin typeface="Calibri"/>
-              </a:defRPr>
-            </a:pPr>
-            <a:r>
-              <a:t>• models/ — trained .keras weights + class_names.json</a:t>
-            </a:r>
-          </a:p>
-          <a:p>
-            <a:pPr>
-              <a:spcAft>
-                <a:spcPts val="800"/>
-              </a:spcAft>
-              <a:defRPr sz="1600">
-                <a:solidFill>
-                  <a:srgbClr val="212121"/>
-                </a:solidFill>
-                <a:latin typeface="Calibri"/>
-              </a:defRPr>
-            </a:pPr>
-            <a:r>
-              <a:t>• Dataset: ./dataset/train (70,295) · ./dataset/valid (17,572)</a:t>
+                <a:spcPts val="900"/>
+              </a:spcAft>
+              <a:defRPr sz="1700">
+                <a:solidFill>
+                  <a:srgbClr val="212121"/>
+                </a:solidFill>
+                <a:latin typeface="Calibri"/>
+              </a:defRPr>
+            </a:pPr>
+            <a:r>
+              <a:t>• Earlier upload bug (4-channel images) found and fixed during testing</a:t>
             </a:r>
           </a:p>
         </p:txBody>
@@ -4578,7 +5350,7 @@
               </a:defRPr>
             </a:pPr>
             <a:r>
-              <a:t>GitHub Repository</a:t>
+              <a:t>Project Files &amp; Structure</a:t>
             </a:r>
           </a:p>
         </p:txBody>
@@ -4591,8 +5363,8 @@
         </p:nvSpPr>
         <p:spPr>
           <a:xfrm>
-            <a:off x="914400" y="1828800"/>
-            <a:ext cx="10332720" cy="914400"/>
+            <a:off x="822960" y="1371600"/>
+            <a:ext cx="10972800" cy="5029200"/>
           </a:xfrm>
           <a:prstGeom prst="rect">
             <a:avLst/>
@@ -4605,16 +5377,147 @@
           </a:bodyPr>
           <a:lstStyle/>
           <a:p>
-            <a:pPr algn="ctr">
-              <a:defRPr sz="2800" b="1">
-                <a:solidFill>
-                  <a:srgbClr val="006699"/>
-                </a:solidFill>
-                <a:latin typeface="Calibri"/>
-              </a:defRPr>
-            </a:pPr>
-            <a:r>
-              <a:t>https://github.com/PG-Sravani/plant-leaf-disease-detection</a:t>
+            <a:pPr>
+              <a:spcAft>
+                <a:spcPts val="800"/>
+              </a:spcAft>
+              <a:defRPr sz="1600">
+                <a:solidFill>
+                  <a:srgbClr val="212121"/>
+                </a:solidFill>
+                <a:latin typeface="Calibri"/>
+              </a:defRPr>
+            </a:pPr>
+            <a:r>
+              <a:t>• plant_disease_detection.py — full 38-class pipeline (all models, Grad-CAM, evaluation)</a:t>
+            </a:r>
+          </a:p>
+          <a:p>
+            <a:pPr>
+              <a:spcAft>
+                <a:spcPts val="800"/>
+              </a:spcAft>
+              <a:defRPr sz="1600">
+                <a:solidFill>
+                  <a:srgbClr val="212121"/>
+                </a:solidFill>
+                <a:latin typeface="Calibri"/>
+              </a:defRPr>
+            </a:pPr>
+            <a:r>
+              <a:t>• plant_disease_detection_quick.py — CPU-friendly 7-class training</a:t>
+            </a:r>
+          </a:p>
+          <a:p>
+            <a:pPr>
+              <a:spcAft>
+                <a:spcPts val="800"/>
+              </a:spcAft>
+              <a:defRPr sz="1600">
+                <a:solidFill>
+                  <a:srgbClr val="212121"/>
+                </a:solidFill>
+                <a:latin typeface="Calibri"/>
+              </a:defRPr>
+            </a:pPr>
+            <a:r>
+              <a:t>• download_dataset.py — automatic Kaggle download</a:t>
+            </a:r>
+          </a:p>
+          <a:p>
+            <a:pPr>
+              <a:spcAft>
+                <a:spcPts val="800"/>
+              </a:spcAft>
+              <a:defRPr sz="1600">
+                <a:solidFill>
+                  <a:srgbClr val="212121"/>
+                </a:solidFill>
+                <a:latin typeface="Calibri"/>
+              </a:defRPr>
+            </a:pPr>
+            <a:r>
+              <a:t>• run_demo.py — Gradio web application</a:t>
+            </a:r>
+          </a:p>
+          <a:p>
+            <a:pPr>
+              <a:spcAft>
+                <a:spcPts val="800"/>
+              </a:spcAft>
+              <a:defRPr sz="1600">
+                <a:solidFill>
+                  <a:srgbClr val="212121"/>
+                </a:solidFill>
+                <a:latin typeface="Calibri"/>
+              </a:defRPr>
+            </a:pPr>
+            <a:r>
+              <a:t>• requirements.txt — dependencies</a:t>
+            </a:r>
+          </a:p>
+          <a:p>
+            <a:pPr>
+              <a:spcAft>
+                <a:spcPts val="800"/>
+              </a:spcAft>
+              <a:defRPr sz="1600">
+                <a:solidFill>
+                  <a:srgbClr val="212121"/>
+                </a:solidFill>
+                <a:latin typeface="Calibri"/>
+              </a:defRPr>
+            </a:pPr>
+            <a:r>
+              <a:t>• README.md · WORKING_PROTOCOL.md — documentation</a:t>
+            </a:r>
+          </a:p>
+          <a:p>
+            <a:pPr>
+              <a:spcAft>
+                <a:spcPts val="800"/>
+              </a:spcAft>
+              <a:defRPr sz="1600">
+                <a:solidFill>
+                  <a:srgbClr val="212121"/>
+                </a:solidFill>
+                <a:latin typeface="Calibri"/>
+              </a:defRPr>
+            </a:pPr>
+            <a:r>
+              <a:t>• results/ — training curve, confusion matrix images</a:t>
+            </a:r>
+          </a:p>
+          <a:p>
+            <a:pPr>
+              <a:spcAft>
+                <a:spcPts val="800"/>
+              </a:spcAft>
+              <a:defRPr sz="1600">
+                <a:solidFill>
+                  <a:srgbClr val="212121"/>
+                </a:solidFill>
+                <a:latin typeface="Calibri"/>
+              </a:defRPr>
+            </a:pPr>
+            <a:r>
+              <a:t>• models/ — trained .keras weights + class_names.json</a:t>
+            </a:r>
+          </a:p>
+          <a:p>
+            <a:pPr>
+              <a:spcAft>
+                <a:spcPts val="800"/>
+              </a:spcAft>
+              <a:defRPr sz="1600">
+                <a:solidFill>
+                  <a:srgbClr val="212121"/>
+                </a:solidFill>
+                <a:latin typeface="Calibri"/>
+              </a:defRPr>
+            </a:pPr>
+            <a:r>
+              <a:t>• Dataset: ./dataset/train (70,295) · ./dataset/valid (17,572)</a:t>
             </a:r>
           </a:p>
         </p:txBody>
@@ -4622,77 +5525,6 @@
       <p:sp>
         <p:nvSpPr>
           <p:cNvPr id="4" name="TextBox 3"/>
-          <p:cNvSpPr txBox="1"/>
-          <p:nvPr/>
-        </p:nvSpPr>
-        <p:spPr>
-          <a:xfrm>
-            <a:off x="1371600" y="3108960"/>
-            <a:ext cx="9418320" cy="3108960"/>
-          </a:xfrm>
-          <a:prstGeom prst="rect">
-            <a:avLst/>
-          </a:prstGeom>
-          <a:noFill/>
-        </p:spPr>
-        <p:txBody>
-          <a:bodyPr wrap="square">
-            <a:spAutoFit/>
-          </a:bodyPr>
-          <a:lstStyle/>
-          <a:p>
-            <a:pPr>
-              <a:spcAft>
-                <a:spcPts val="800"/>
-              </a:spcAft>
-              <a:defRPr sz="1700">
-                <a:solidFill>
-                  <a:srgbClr val="212121"/>
-                </a:solidFill>
-                <a:latin typeface="Calibri"/>
-              </a:defRPr>
-            </a:pPr>
-            <a:r>
-              <a:t>• Public repo — all code, trained model, result images and docs</a:t>
-            </a:r>
-          </a:p>
-          <a:p>
-            <a:pPr>
-              <a:spcAft>
-                <a:spcPts val="800"/>
-              </a:spcAft>
-              <a:defRPr sz="1700">
-                <a:solidFill>
-                  <a:srgbClr val="212121"/>
-                </a:solidFill>
-                <a:latin typeface="Calibri"/>
-              </a:defRPr>
-            </a:pPr>
-            <a:r>
-              <a:t>• Commits trace the full workflow: setup → data → training → demo → fix</a:t>
-            </a:r>
-          </a:p>
-          <a:p>
-            <a:pPr>
-              <a:spcAft>
-                <a:spcPts val="800"/>
-              </a:spcAft>
-              <a:defRPr sz="1700">
-                <a:solidFill>
-                  <a:srgbClr val="212121"/>
-                </a:solidFill>
-                <a:latin typeface="Calibri"/>
-              </a:defRPr>
-            </a:pPr>
-            <a:r>
-              <a:t>• Clone &amp; reproduce:  git clone https://github.com/PG-Sravani/…</a:t>
-            </a:r>
-          </a:p>
-        </p:txBody>
-      </p:sp>
-      <p:sp>
-        <p:nvSpPr>
-          <p:cNvPr id="5" name="TextBox 4"/>
           <p:cNvSpPr txBox="1"/>
           <p:nvPr/>
         </p:nvSpPr>
@@ -4800,7 +5632,7 @@
               </a:defRPr>
             </a:pPr>
             <a:r>
-              <a:t>Conclusion &amp; Learning Outcomes</a:t>
+              <a:t>GitHub Repository</a:t>
             </a:r>
           </a:p>
         </p:txBody>
@@ -4813,8 +5645,8 @@
         </p:nvSpPr>
         <p:spPr>
           <a:xfrm>
-            <a:off x="822960" y="1463040"/>
-            <a:ext cx="10515600" cy="4937760"/>
+            <a:off x="914400" y="1828800"/>
+            <a:ext cx="10332720" cy="914400"/>
           </a:xfrm>
           <a:prstGeom prst="rect">
             <a:avLst/>
@@ -4827,9 +5659,45 @@
           </a:bodyPr>
           <a:lstStyle/>
           <a:p>
+            <a:pPr algn="ctr">
+              <a:defRPr sz="2800" b="1">
+                <a:solidFill>
+                  <a:srgbClr val="006699"/>
+                </a:solidFill>
+                <a:latin typeface="Calibri"/>
+              </a:defRPr>
+            </a:pPr>
+            <a:r>
+              <a:t>https://github.com/PG-Sravani/plant-leaf-disease-detection</a:t>
+            </a:r>
+          </a:p>
+        </p:txBody>
+      </p:sp>
+      <p:sp>
+        <p:nvSpPr>
+          <p:cNvPr id="4" name="TextBox 3"/>
+          <p:cNvSpPr txBox="1"/>
+          <p:nvPr/>
+        </p:nvSpPr>
+        <p:spPr>
+          <a:xfrm>
+            <a:off x="1371600" y="3108960"/>
+            <a:ext cx="9418320" cy="3108960"/>
+          </a:xfrm>
+          <a:prstGeom prst="rect">
+            <a:avLst/>
+          </a:prstGeom>
+          <a:noFill/>
+        </p:spPr>
+        <p:txBody>
+          <a:bodyPr wrap="square">
+            <a:spAutoFit/>
+          </a:bodyPr>
+          <a:lstStyle/>
+          <a:p>
             <a:pPr>
               <a:spcAft>
-                <a:spcPts val="1000"/>
+                <a:spcPts val="800"/>
               </a:spcAft>
               <a:defRPr sz="1700">
                 <a:solidFill>
@@ -4839,13 +5707,13 @@
               </a:defRPr>
             </a:pPr>
             <a:r>
-              <a:t>• Demonstrated an end-to-end deep learning pipeline for plant leaf disease detection on real Kaggle data.</a:t>
+              <a:t>• Public repo — all code, trained model, result images and docs</a:t>
             </a:r>
           </a:p>
           <a:p>
             <a:pPr>
               <a:spcAft>
-                <a:spcPts val="1000"/>
+                <a:spcPts val="800"/>
               </a:spcAft>
               <a:defRPr sz="1700">
                 <a:solidFill>
@@ -4855,13 +5723,13 @@
               </a:defRPr>
             </a:pPr>
             <a:r>
-              <a:t>• Achieved ~88% validation accuracy on a 7-class quick model using MobileNetV2 transfer learning (CPU-only environment).</a:t>
+              <a:t>• Commits trace the full workflow: setup → data → training → demo → fix</a:t>
             </a:r>
           </a:p>
           <a:p>
             <a:pPr>
               <a:spcAft>
-                <a:spcPts val="1000"/>
+                <a:spcPts val="800"/>
               </a:spcAft>
               <a:defRPr sz="1700">
                 <a:solidFill>
@@ -4871,46 +5739,14 @@
               </a:defRPr>
             </a:pPr>
             <a:r>
-              <a:t>• Full 38-class support with multiple backbones and automatic evaluation, Grad-CAM, and a deployable web UI.</a:t>
-            </a:r>
-          </a:p>
-          <a:p>
-            <a:pPr>
-              <a:spcAft>
-                <a:spcPts val="1000"/>
-              </a:spcAft>
-              <a:defRPr sz="1700">
-                <a:solidFill>
-                  <a:srgbClr val="212121"/>
-                </a:solidFill>
-                <a:latin typeface="Calibri"/>
-              </a:defRPr>
-            </a:pPr>
-            <a:r>
-              <a:t>• Learned: dataset handling, augmentation, transfer learning, callbacks, evaluation metrics, model interpretability, deployment.</a:t>
-            </a:r>
-          </a:p>
-          <a:p>
-            <a:pPr>
-              <a:spcAft>
-                <a:spcPts val="1000"/>
-              </a:spcAft>
-              <a:defRPr sz="1700">
-                <a:solidFill>
-                  <a:srgbClr val="212121"/>
-                </a:solidFill>
-                <a:latin typeface="Calibri"/>
-              </a:defRPr>
-            </a:pPr>
-            <a:r>
-              <a:t>• Real bug-fixing experience: dataset cache structure, Keras 3 API changes, and RGBA image upload handling.</a:t>
-            </a:r>
-          </a:p>
-        </p:txBody>
-      </p:sp>
-      <p:sp>
-        <p:nvSpPr>
-          <p:cNvPr id="4" name="TextBox 3"/>
+              <a:t>• Clone &amp; reproduce:  git clone https://github.com/PG-Sravani/…</a:t>
+            </a:r>
+          </a:p>
+        </p:txBody>
+      </p:sp>
+      <p:sp>
+        <p:nvSpPr>
+          <p:cNvPr id="5" name="TextBox 4"/>
           <p:cNvSpPr txBox="1"/>
           <p:nvPr/>
         </p:nvSpPr>
@@ -5018,7 +5854,7 @@
               </a:defRPr>
             </a:pPr>
             <a:r>
-              <a:t>Future Work</a:t>
+              <a:t>Conclusion &amp; Learning Outcomes</a:t>
             </a:r>
           </a:p>
         </p:txBody>
@@ -5032,7 +5868,7 @@
         <p:spPr>
           <a:xfrm>
             <a:off x="822960" y="1463040"/>
-            <a:ext cx="10515600" cy="4572000"/>
+            <a:ext cx="10515600" cy="4937760"/>
           </a:xfrm>
           <a:prstGeom prst="rect">
             <a:avLst/>
@@ -5057,7 +5893,7 @@
               </a:defRPr>
             </a:pPr>
             <a:r>
-              <a:t>• Train the full 38-class model on a GPU for production accuracy (&gt;98% typical on this dataset).</a:t>
+              <a:t>• Demonstrated an end-to-end deep learning pipeline for plant leaf disease detection on real Kaggle data.</a:t>
             </a:r>
           </a:p>
           <a:p>
@@ -5073,7 +5909,7 @@
               </a:defRPr>
             </a:pPr>
             <a:r>
-              <a:t>• Fine-tune frozen backbones by unfreezing top layers.</a:t>
+              <a:t>• Achieved ~88% validation accuracy on a 7-class quick model using MobileNetV2 transfer learning (CPU-only environment).</a:t>
             </a:r>
           </a:p>
           <a:p>
@@ -5089,7 +5925,7 @@
               </a:defRPr>
             </a:pPr>
             <a:r>
-              <a:t>• Add per-disease treatment/precaution advice in the web app.</a:t>
+              <a:t>• Full 38-class support with multiple backbones and automatic evaluation, Grad-CAM, and a deployable web UI.</a:t>
             </a:r>
           </a:p>
           <a:p>
@@ -5105,7 +5941,7 @@
               </a:defRPr>
             </a:pPr>
             <a:r>
-              <a:t>• Extend to object detection (bounding boxes) and mobile edge devices.</a:t>
+              <a:t>• Learned: dataset handling, augmentation, transfer learning, callbacks, evaluation metrics, model interpretability, deployment.</a:t>
             </a:r>
           </a:p>
           <a:p>
@@ -5121,7 +5957,7 @@
               </a:defRPr>
             </a:pPr>
             <a:r>
-              <a:t>• Add confidence-based "uncertain" flagging to flag uncertain cases for expert review.</a:t>
+              <a:t>• Real bug-fixing experience: dataset cache structure, Keras 3 API changes, and RGBA image upload handling.</a:t>
             </a:r>
           </a:p>
         </p:txBody>
@@ -5171,104 +6007,6 @@
 </file>
 
 <file path=ppt/slides/slide19.xml><?xml version="1.0" encoding="utf-8"?>
-<p:sld xmlns:a="http://schemas.openxmlformats.org/drawingml/2006/main" xmlns:p="http://schemas.openxmlformats.org/presentationml/2006/main" xmlns:r="http://schemas.openxmlformats.org/officeDocument/2006/relationships">
-  <p:cSld>
-    <p:bg>
-      <p:bgPr>
-        <a:solidFill>
-          <a:srgbClr val="1B5E20"/>
-        </a:solidFill>
-        <a:effectLst/>
-      </p:bgPr>
-    </p:bg>
-    <p:spTree>
-      <p:nvGrpSpPr>
-        <p:cNvPr id="1" name=""/>
-        <p:cNvGrpSpPr/>
-        <p:nvPr/>
-      </p:nvGrpSpPr>
-      <p:grpSpPr/>
-      <p:sp>
-        <p:nvSpPr>
-          <p:cNvPr id="2" name="TextBox 1"/>
-          <p:cNvSpPr txBox="1"/>
-          <p:nvPr/>
-        </p:nvSpPr>
-        <p:spPr>
-          <a:xfrm>
-            <a:off x="1097280" y="2560320"/>
-            <a:ext cx="9966960" cy="1463040"/>
-          </a:xfrm>
-          <a:prstGeom prst="rect">
-            <a:avLst/>
-          </a:prstGeom>
-          <a:noFill/>
-        </p:spPr>
-        <p:txBody>
-          <a:bodyPr wrap="none">
-            <a:spAutoFit/>
-          </a:bodyPr>
-          <a:lstStyle/>
-          <a:p>
-            <a:pPr algn="ctr">
-              <a:defRPr sz="4800" b="1">
-                <a:solidFill>
-                  <a:srgbClr val="FFFFFF"/>
-                </a:solidFill>
-                <a:latin typeface="Calibri"/>
-              </a:defRPr>
-            </a:pPr>
-            <a:r>
-              <a:t>Thank You</a:t>
-            </a:r>
-          </a:p>
-        </p:txBody>
-      </p:sp>
-      <p:sp>
-        <p:nvSpPr>
-          <p:cNvPr id="3" name="TextBox 2"/>
-          <p:cNvSpPr txBox="1"/>
-          <p:nvPr/>
-        </p:nvSpPr>
-        <p:spPr>
-          <a:xfrm>
-            <a:off x="1097280" y="4023360"/>
-            <a:ext cx="9966960" cy="1097280"/>
-          </a:xfrm>
-          <a:prstGeom prst="rect">
-            <a:avLst/>
-          </a:prstGeom>
-          <a:noFill/>
-        </p:spPr>
-        <p:txBody>
-          <a:bodyPr wrap="none">
-            <a:spAutoFit/>
-          </a:bodyPr>
-          <a:lstStyle/>
-          <a:p>
-            <a:pPr algn="ctr">
-              <a:defRPr sz="2200">
-                <a:solidFill>
-                  <a:srgbClr val="A5D6A7"/>
-                </a:solidFill>
-                <a:latin typeface="Calibri"/>
-              </a:defRPr>
-            </a:pPr>
-            <a:r>
-              <a:t>Questions &amp; Discussion</a:t>
-            </a:r>
-          </a:p>
-        </p:txBody>
-      </p:sp>
-    </p:spTree>
-  </p:cSld>
-  <p:clrMapOvr>
-    <a:masterClrMapping/>
-  </p:clrMapOvr>
-</p:sld>
-</file>
-
-<file path=ppt/slides/slide2.xml><?xml version="1.0" encoding="utf-8"?>
 <p:sld xmlns:a="http://schemas.openxmlformats.org/drawingml/2006/main" xmlns:p="http://schemas.openxmlformats.org/presentationml/2006/main" xmlns:r="http://schemas.openxmlformats.org/officeDocument/2006/relationships">
   <p:cSld>
     <p:bg>
@@ -5334,6 +6072,224 @@
               </a:defRPr>
             </a:pPr>
             <a:r>
+              <a:t>Future Work</a:t>
+            </a:r>
+          </a:p>
+        </p:txBody>
+      </p:sp>
+      <p:sp>
+        <p:nvSpPr>
+          <p:cNvPr id="3" name="TextBox 2"/>
+          <p:cNvSpPr txBox="1"/>
+          <p:nvPr/>
+        </p:nvSpPr>
+        <p:spPr>
+          <a:xfrm>
+            <a:off x="822960" y="1463040"/>
+            <a:ext cx="10515600" cy="4572000"/>
+          </a:xfrm>
+          <a:prstGeom prst="rect">
+            <a:avLst/>
+          </a:prstGeom>
+          <a:noFill/>
+        </p:spPr>
+        <p:txBody>
+          <a:bodyPr wrap="square">
+            <a:spAutoFit/>
+          </a:bodyPr>
+          <a:lstStyle/>
+          <a:p>
+            <a:pPr>
+              <a:spcAft>
+                <a:spcPts val="1000"/>
+              </a:spcAft>
+              <a:defRPr sz="1700">
+                <a:solidFill>
+                  <a:srgbClr val="212121"/>
+                </a:solidFill>
+                <a:latin typeface="Calibri"/>
+              </a:defRPr>
+            </a:pPr>
+            <a:r>
+              <a:t>• Train the full 38-class model on a GPU for production accuracy (&gt;98% typical on this dataset).</a:t>
+            </a:r>
+          </a:p>
+          <a:p>
+            <a:pPr>
+              <a:spcAft>
+                <a:spcPts val="1000"/>
+              </a:spcAft>
+              <a:defRPr sz="1700">
+                <a:solidFill>
+                  <a:srgbClr val="212121"/>
+                </a:solidFill>
+                <a:latin typeface="Calibri"/>
+              </a:defRPr>
+            </a:pPr>
+            <a:r>
+              <a:t>• Fine-tune frozen backbones by unfreezing top layers.</a:t>
+            </a:r>
+          </a:p>
+          <a:p>
+            <a:pPr>
+              <a:spcAft>
+                <a:spcPts val="1000"/>
+              </a:spcAft>
+              <a:defRPr sz="1700">
+                <a:solidFill>
+                  <a:srgbClr val="212121"/>
+                </a:solidFill>
+                <a:latin typeface="Calibri"/>
+              </a:defRPr>
+            </a:pPr>
+            <a:r>
+              <a:t>• Add per-disease treatment/precaution advice in the web app.</a:t>
+            </a:r>
+          </a:p>
+          <a:p>
+            <a:pPr>
+              <a:spcAft>
+                <a:spcPts val="1000"/>
+              </a:spcAft>
+              <a:defRPr sz="1700">
+                <a:solidFill>
+                  <a:srgbClr val="212121"/>
+                </a:solidFill>
+                <a:latin typeface="Calibri"/>
+              </a:defRPr>
+            </a:pPr>
+            <a:r>
+              <a:t>• Extend to object detection (bounding boxes) and mobile edge devices.</a:t>
+            </a:r>
+          </a:p>
+          <a:p>
+            <a:pPr>
+              <a:spcAft>
+                <a:spcPts val="1000"/>
+              </a:spcAft>
+              <a:defRPr sz="1700">
+                <a:solidFill>
+                  <a:srgbClr val="212121"/>
+                </a:solidFill>
+                <a:latin typeface="Calibri"/>
+              </a:defRPr>
+            </a:pPr>
+            <a:r>
+              <a:t>• Add confidence-based "uncertain" flagging to flag uncertain cases for expert review.</a:t>
+            </a:r>
+          </a:p>
+        </p:txBody>
+      </p:sp>
+      <p:sp>
+        <p:nvSpPr>
+          <p:cNvPr id="4" name="TextBox 3"/>
+          <p:cNvSpPr txBox="1"/>
+          <p:nvPr/>
+        </p:nvSpPr>
+        <p:spPr>
+          <a:xfrm>
+            <a:off x="10424160" y="6400800"/>
+            <a:ext cx="1554480" cy="365760"/>
+          </a:xfrm>
+          <a:prstGeom prst="rect">
+            <a:avLst/>
+          </a:prstGeom>
+          <a:noFill/>
+        </p:spPr>
+        <p:txBody>
+          <a:bodyPr wrap="none">
+            <a:spAutoFit/>
+          </a:bodyPr>
+          <a:lstStyle/>
+          <a:p>
+            <a:pPr algn="r">
+              <a:defRPr sz="1100">
+                <a:solidFill>
+                  <a:srgbClr val="1B5E20"/>
+                </a:solidFill>
+                <a:latin typeface="Calibri"/>
+              </a:defRPr>
+            </a:pPr>
+            <a:r>
+              <a:t>IVA CIA-3 · 19</a:t>
+            </a:r>
+          </a:p>
+        </p:txBody>
+      </p:sp>
+    </p:spTree>
+  </p:cSld>
+  <p:clrMapOvr>
+    <a:masterClrMapping/>
+  </p:clrMapOvr>
+</p:sld>
+</file>
+
+<file path=ppt/slides/slide2.xml><?xml version="1.0" encoding="utf-8"?>
+<p:sld xmlns:a="http://schemas.openxmlformats.org/drawingml/2006/main" xmlns:p="http://schemas.openxmlformats.org/presentationml/2006/main" xmlns:r="http://schemas.openxmlformats.org/officeDocument/2006/relationships">
+  <p:cSld>
+    <p:bg>
+      <p:bgPr>
+        <a:solidFill>
+          <a:srgbClr val="FBFAF0"/>
+        </a:solidFill>
+        <a:effectLst/>
+      </p:bgPr>
+    </p:bg>
+    <p:spTree>
+      <p:nvGrpSpPr>
+        <p:cNvPr id="1" name=""/>
+        <p:cNvGrpSpPr/>
+        <p:nvPr/>
+      </p:nvGrpSpPr>
+      <p:grpSpPr/>
+      <p:sp>
+        <p:nvSpPr>
+          <p:cNvPr id="2" name="Rectangle 1"/>
+          <p:cNvSpPr/>
+          <p:nvPr/>
+        </p:nvSpPr>
+        <p:spPr>
+          <a:xfrm>
+            <a:off x="0" y="0"/>
+            <a:ext cx="12188952" cy="960120"/>
+          </a:xfrm>
+          <a:prstGeom prst="rect">
+            <a:avLst/>
+          </a:prstGeom>
+          <a:solidFill>
+            <a:srgbClr val="2E7D32"/>
+          </a:solidFill>
+          <a:ln>
+            <a:noFill/>
+          </a:ln>
+        </p:spPr>
+        <p:style>
+          <a:lnRef idx="1">
+            <a:schemeClr val="accent1"/>
+          </a:lnRef>
+          <a:fillRef idx="3">
+            <a:schemeClr val="accent1"/>
+          </a:fillRef>
+          <a:effectRef idx="2">
+            <a:schemeClr val="accent1"/>
+          </a:effectRef>
+          <a:fontRef idx="minor">
+            <a:schemeClr val="lt1"/>
+          </a:fontRef>
+        </p:style>
+        <p:txBody>
+          <a:bodyPr rtlCol="0" anchor="ctr" lIns="365760"/>
+          <a:lstStyle/>
+          <a:p>
+            <a:pPr algn="ctr">
+              <a:defRPr sz="3000" b="1">
+                <a:solidFill>
+                  <a:srgbClr val="FFFFFF"/>
+                </a:solidFill>
+                <a:latin typeface="Calibri"/>
+              </a:defRPr>
+            </a:pPr>
+            <a:r>
               <a:t>Agenda</a:t>
             </a:r>
           </a:p>
@@ -5538,6 +6494,104 @@
             </a:pPr>
             <a:r>
               <a:t>IVA CIA-3 · 2</a:t>
+            </a:r>
+          </a:p>
+        </p:txBody>
+      </p:sp>
+    </p:spTree>
+  </p:cSld>
+  <p:clrMapOvr>
+    <a:masterClrMapping/>
+  </p:clrMapOvr>
+</p:sld>
+</file>
+
+<file path=ppt/slides/slide20.xml><?xml version="1.0" encoding="utf-8"?>
+<p:sld xmlns:a="http://schemas.openxmlformats.org/drawingml/2006/main" xmlns:p="http://schemas.openxmlformats.org/presentationml/2006/main" xmlns:r="http://schemas.openxmlformats.org/officeDocument/2006/relationships">
+  <p:cSld>
+    <p:bg>
+      <p:bgPr>
+        <a:solidFill>
+          <a:srgbClr val="1B5E20"/>
+        </a:solidFill>
+        <a:effectLst/>
+      </p:bgPr>
+    </p:bg>
+    <p:spTree>
+      <p:nvGrpSpPr>
+        <p:cNvPr id="1" name=""/>
+        <p:cNvGrpSpPr/>
+        <p:nvPr/>
+      </p:nvGrpSpPr>
+      <p:grpSpPr/>
+      <p:sp>
+        <p:nvSpPr>
+          <p:cNvPr id="2" name="TextBox 1"/>
+          <p:cNvSpPr txBox="1"/>
+          <p:nvPr/>
+        </p:nvSpPr>
+        <p:spPr>
+          <a:xfrm>
+            <a:off x="1097280" y="2560320"/>
+            <a:ext cx="9966960" cy="1463040"/>
+          </a:xfrm>
+          <a:prstGeom prst="rect">
+            <a:avLst/>
+          </a:prstGeom>
+          <a:noFill/>
+        </p:spPr>
+        <p:txBody>
+          <a:bodyPr wrap="none">
+            <a:spAutoFit/>
+          </a:bodyPr>
+          <a:lstStyle/>
+          <a:p>
+            <a:pPr algn="ctr">
+              <a:defRPr sz="4800" b="1">
+                <a:solidFill>
+                  <a:srgbClr val="FFFFFF"/>
+                </a:solidFill>
+                <a:latin typeface="Calibri"/>
+              </a:defRPr>
+            </a:pPr>
+            <a:r>
+              <a:t>Thank You</a:t>
+            </a:r>
+          </a:p>
+        </p:txBody>
+      </p:sp>
+      <p:sp>
+        <p:nvSpPr>
+          <p:cNvPr id="3" name="TextBox 2"/>
+          <p:cNvSpPr txBox="1"/>
+          <p:nvPr/>
+        </p:nvSpPr>
+        <p:spPr>
+          <a:xfrm>
+            <a:off x="1097280" y="4023360"/>
+            <a:ext cx="9966960" cy="1097280"/>
+          </a:xfrm>
+          <a:prstGeom prst="rect">
+            <a:avLst/>
+          </a:prstGeom>
+          <a:noFill/>
+        </p:spPr>
+        <p:txBody>
+          <a:bodyPr wrap="none">
+            <a:spAutoFit/>
+          </a:bodyPr>
+          <a:lstStyle/>
+          <a:p>
+            <a:pPr algn="ctr">
+              <a:defRPr sz="2200">
+                <a:solidFill>
+                  <a:srgbClr val="A5D6A7"/>
+                </a:solidFill>
+                <a:latin typeface="Calibri"/>
+              </a:defRPr>
+            </a:pPr>
+            <a:r>
+              <a:t>Questions &amp; Discussion</a:t>
             </a:r>
           </a:p>
         </p:txBody>

</xml_diff>

<commit_message>
Add dedicated sample-output slide with live demo screenshot (slide 16)
</commit_message>
<xml_diff>
--- a/Plant_Leaf_Disease_Detection_IVACIA3.pptx
+++ b/Plant_Leaf_Disease_Detection_IVACIA3.pptx
@@ -25,6 +25,7 @@
     <p:sldId id="273" r:id="rId24"/>
     <p:sldId id="274" r:id="rId25"/>
     <p:sldId id="275" r:id="rId26"/>
+    <p:sldId id="276" r:id="rId27"/>
   </p:sldIdLst>
   <p:sldSz cx="12191695" cy="6858000" type="screen4x3"/>
   <p:notesSz cx="6858000" cy="9144000"/>
@@ -5350,21 +5351,45 @@
               </a:defRPr>
             </a:pPr>
             <a:r>
-              <a:t>Project Files &amp; Structure</a:t>
-            </a:r>
-          </a:p>
-        </p:txBody>
-      </p:sp>
-      <p:sp>
-        <p:nvSpPr>
-          <p:cNvPr id="3" name="TextBox 2"/>
+              <a:t>Sample Output — Disease Prediction</a:t>
+            </a:r>
+          </a:p>
+        </p:txBody>
+      </p:sp>
+      <p:pic>
+        <p:nvPicPr>
+          <p:cNvPr id="3" name="Picture 2" descr="output_sample.png"/>
+          <p:cNvPicPr>
+            <a:picLocks noChangeAspect="1"/>
+          </p:cNvPicPr>
+          <p:nvPr/>
+        </p:nvPicPr>
+        <p:blipFill>
+          <a:blip r:embed="rId2"/>
+          <a:stretch>
+            <a:fillRect/>
+          </a:stretch>
+        </p:blipFill>
+        <p:spPr>
+          <a:xfrm>
+            <a:off x="1109401" y="1645920"/>
+            <a:ext cx="9972892" cy="4023360"/>
+          </a:xfrm>
+          <a:prstGeom prst="rect">
+            <a:avLst/>
+          </a:prstGeom>
+        </p:spPr>
+      </p:pic>
+      <p:sp>
+        <p:nvSpPr>
+          <p:cNvPr id="4" name="TextBox 3"/>
           <p:cNvSpPr txBox="1"/>
           <p:nvPr/>
         </p:nvSpPr>
         <p:spPr>
           <a:xfrm>
-            <a:off x="822960" y="1371600"/>
-            <a:ext cx="10972800" cy="5029200"/>
+            <a:off x="914400" y="5943600"/>
+            <a:ext cx="10332720" cy="731520"/>
           </a:xfrm>
           <a:prstGeom prst="rect">
             <a:avLst/>
@@ -5377,154 +5402,23 @@
           </a:bodyPr>
           <a:lstStyle/>
           <a:p>
-            <a:pPr>
-              <a:spcAft>
-                <a:spcPts val="800"/>
-              </a:spcAft>
-              <a:defRPr sz="1600">
-                <a:solidFill>
-                  <a:srgbClr val="212121"/>
-                </a:solidFill>
-                <a:latin typeface="Calibri"/>
-              </a:defRPr>
-            </a:pPr>
-            <a:r>
-              <a:t>• plant_disease_detection.py — full 38-class pipeline (all models, Grad-CAM, evaluation)</a:t>
-            </a:r>
-          </a:p>
-          <a:p>
-            <a:pPr>
-              <a:spcAft>
-                <a:spcPts val="800"/>
-              </a:spcAft>
-              <a:defRPr sz="1600">
-                <a:solidFill>
-                  <a:srgbClr val="212121"/>
-                </a:solidFill>
-                <a:latin typeface="Calibri"/>
-              </a:defRPr>
-            </a:pPr>
-            <a:r>
-              <a:t>• plant_disease_detection_quick.py — CPU-friendly 7-class training</a:t>
-            </a:r>
-          </a:p>
-          <a:p>
-            <a:pPr>
-              <a:spcAft>
-                <a:spcPts val="800"/>
-              </a:spcAft>
-              <a:defRPr sz="1600">
-                <a:solidFill>
-                  <a:srgbClr val="212121"/>
-                </a:solidFill>
-                <a:latin typeface="Calibri"/>
-              </a:defRPr>
-            </a:pPr>
-            <a:r>
-              <a:t>• download_dataset.py — automatic Kaggle download</a:t>
-            </a:r>
-          </a:p>
-          <a:p>
-            <a:pPr>
-              <a:spcAft>
-                <a:spcPts val="800"/>
-              </a:spcAft>
-              <a:defRPr sz="1600">
-                <a:solidFill>
-                  <a:srgbClr val="212121"/>
-                </a:solidFill>
-                <a:latin typeface="Calibri"/>
-              </a:defRPr>
-            </a:pPr>
-            <a:r>
-              <a:t>• run_demo.py — Gradio web application</a:t>
-            </a:r>
-          </a:p>
-          <a:p>
-            <a:pPr>
-              <a:spcAft>
-                <a:spcPts val="800"/>
-              </a:spcAft>
-              <a:defRPr sz="1600">
-                <a:solidFill>
-                  <a:srgbClr val="212121"/>
-                </a:solidFill>
-                <a:latin typeface="Calibri"/>
-              </a:defRPr>
-            </a:pPr>
-            <a:r>
-              <a:t>• requirements.txt — dependencies</a:t>
-            </a:r>
-          </a:p>
-          <a:p>
-            <a:pPr>
-              <a:spcAft>
-                <a:spcPts val="800"/>
-              </a:spcAft>
-              <a:defRPr sz="1600">
-                <a:solidFill>
-                  <a:srgbClr val="212121"/>
-                </a:solidFill>
-                <a:latin typeface="Calibri"/>
-              </a:defRPr>
-            </a:pPr>
-            <a:r>
-              <a:t>• README.md · WORKING_PROTOCOL.md — documentation</a:t>
-            </a:r>
-          </a:p>
-          <a:p>
-            <a:pPr>
-              <a:spcAft>
-                <a:spcPts val="800"/>
-              </a:spcAft>
-              <a:defRPr sz="1600">
-                <a:solidFill>
-                  <a:srgbClr val="212121"/>
-                </a:solidFill>
-                <a:latin typeface="Calibri"/>
-              </a:defRPr>
-            </a:pPr>
-            <a:r>
-              <a:t>• results/ — training curve, confusion matrix images</a:t>
-            </a:r>
-          </a:p>
-          <a:p>
-            <a:pPr>
-              <a:spcAft>
-                <a:spcPts val="800"/>
-              </a:spcAft>
-              <a:defRPr sz="1600">
-                <a:solidFill>
-                  <a:srgbClr val="212121"/>
-                </a:solidFill>
-                <a:latin typeface="Calibri"/>
-              </a:defRPr>
-            </a:pPr>
-            <a:r>
-              <a:t>• models/ — trained .keras weights + class_names.json</a:t>
-            </a:r>
-          </a:p>
-          <a:p>
-            <a:pPr>
-              <a:spcAft>
-                <a:spcPts val="800"/>
-              </a:spcAft>
-              <a:defRPr sz="1600">
-                <a:solidFill>
-                  <a:srgbClr val="212121"/>
-                </a:solidFill>
-                <a:latin typeface="Calibri"/>
-              </a:defRPr>
-            </a:pPr>
-            <a:r>
-              <a:t>• Dataset: ./dataset/train (70,295) · ./dataset/valid (17,572)</a:t>
-            </a:r>
-          </a:p>
-        </p:txBody>
-      </p:sp>
-      <p:sp>
-        <p:nvSpPr>
-          <p:cNvPr id="4" name="TextBox 3"/>
+            <a:pPr algn="ctr">
+              <a:defRPr sz="1400" b="0">
+                <a:solidFill>
+                  <a:srgbClr val="212121"/>
+                </a:solidFill>
+                <a:latin typeface="Calibri"/>
+              </a:defRPr>
+            </a:pPr>
+            <a:r>
+              <a:t>Uploaded leaf photo → predicted disease + confidence, rendered by the Gradio web application (runtime screenshot)</a:t>
+            </a:r>
+          </a:p>
+        </p:txBody>
+      </p:sp>
+      <p:sp>
+        <p:nvSpPr>
+          <p:cNvPr id="5" name="TextBox 4"/>
           <p:cNvSpPr txBox="1"/>
           <p:nvPr/>
         </p:nvSpPr>
@@ -5632,7 +5526,7 @@
               </a:defRPr>
             </a:pPr>
             <a:r>
-              <a:t>GitHub Repository</a:t>
+              <a:t>Project Files &amp; Structure</a:t>
             </a:r>
           </a:p>
         </p:txBody>
@@ -5645,8 +5539,8 @@
         </p:nvSpPr>
         <p:spPr>
           <a:xfrm>
-            <a:off x="914400" y="1828800"/>
-            <a:ext cx="10332720" cy="914400"/>
+            <a:off x="822960" y="1371600"/>
+            <a:ext cx="10972800" cy="5029200"/>
           </a:xfrm>
           <a:prstGeom prst="rect">
             <a:avLst/>
@@ -5659,16 +5553,147 @@
           </a:bodyPr>
           <a:lstStyle/>
           <a:p>
-            <a:pPr algn="ctr">
-              <a:defRPr sz="2800" b="1">
-                <a:solidFill>
-                  <a:srgbClr val="006699"/>
-                </a:solidFill>
-                <a:latin typeface="Calibri"/>
-              </a:defRPr>
-            </a:pPr>
-            <a:r>
-              <a:t>https://github.com/PG-Sravani/plant-leaf-disease-detection</a:t>
+            <a:pPr>
+              <a:spcAft>
+                <a:spcPts val="800"/>
+              </a:spcAft>
+              <a:defRPr sz="1600">
+                <a:solidFill>
+                  <a:srgbClr val="212121"/>
+                </a:solidFill>
+                <a:latin typeface="Calibri"/>
+              </a:defRPr>
+            </a:pPr>
+            <a:r>
+              <a:t>• plant_disease_detection.py — full 38-class pipeline (all models, Grad-CAM, evaluation)</a:t>
+            </a:r>
+          </a:p>
+          <a:p>
+            <a:pPr>
+              <a:spcAft>
+                <a:spcPts val="800"/>
+              </a:spcAft>
+              <a:defRPr sz="1600">
+                <a:solidFill>
+                  <a:srgbClr val="212121"/>
+                </a:solidFill>
+                <a:latin typeface="Calibri"/>
+              </a:defRPr>
+            </a:pPr>
+            <a:r>
+              <a:t>• plant_disease_detection_quick.py — CPU-friendly 7-class training</a:t>
+            </a:r>
+          </a:p>
+          <a:p>
+            <a:pPr>
+              <a:spcAft>
+                <a:spcPts val="800"/>
+              </a:spcAft>
+              <a:defRPr sz="1600">
+                <a:solidFill>
+                  <a:srgbClr val="212121"/>
+                </a:solidFill>
+                <a:latin typeface="Calibri"/>
+              </a:defRPr>
+            </a:pPr>
+            <a:r>
+              <a:t>• download_dataset.py — automatic Kaggle download</a:t>
+            </a:r>
+          </a:p>
+          <a:p>
+            <a:pPr>
+              <a:spcAft>
+                <a:spcPts val="800"/>
+              </a:spcAft>
+              <a:defRPr sz="1600">
+                <a:solidFill>
+                  <a:srgbClr val="212121"/>
+                </a:solidFill>
+                <a:latin typeface="Calibri"/>
+              </a:defRPr>
+            </a:pPr>
+            <a:r>
+              <a:t>• run_demo.py — Gradio web application</a:t>
+            </a:r>
+          </a:p>
+          <a:p>
+            <a:pPr>
+              <a:spcAft>
+                <a:spcPts val="800"/>
+              </a:spcAft>
+              <a:defRPr sz="1600">
+                <a:solidFill>
+                  <a:srgbClr val="212121"/>
+                </a:solidFill>
+                <a:latin typeface="Calibri"/>
+              </a:defRPr>
+            </a:pPr>
+            <a:r>
+              <a:t>• requirements.txt — dependencies</a:t>
+            </a:r>
+          </a:p>
+          <a:p>
+            <a:pPr>
+              <a:spcAft>
+                <a:spcPts val="800"/>
+              </a:spcAft>
+              <a:defRPr sz="1600">
+                <a:solidFill>
+                  <a:srgbClr val="212121"/>
+                </a:solidFill>
+                <a:latin typeface="Calibri"/>
+              </a:defRPr>
+            </a:pPr>
+            <a:r>
+              <a:t>• README.md · WORKING_PROTOCOL.md — documentation</a:t>
+            </a:r>
+          </a:p>
+          <a:p>
+            <a:pPr>
+              <a:spcAft>
+                <a:spcPts val="800"/>
+              </a:spcAft>
+              <a:defRPr sz="1600">
+                <a:solidFill>
+                  <a:srgbClr val="212121"/>
+                </a:solidFill>
+                <a:latin typeface="Calibri"/>
+              </a:defRPr>
+            </a:pPr>
+            <a:r>
+              <a:t>• results/ — training curve, confusion matrix images</a:t>
+            </a:r>
+          </a:p>
+          <a:p>
+            <a:pPr>
+              <a:spcAft>
+                <a:spcPts val="800"/>
+              </a:spcAft>
+              <a:defRPr sz="1600">
+                <a:solidFill>
+                  <a:srgbClr val="212121"/>
+                </a:solidFill>
+                <a:latin typeface="Calibri"/>
+              </a:defRPr>
+            </a:pPr>
+            <a:r>
+              <a:t>• models/ — trained .keras weights + class_names.json</a:t>
+            </a:r>
+          </a:p>
+          <a:p>
+            <a:pPr>
+              <a:spcAft>
+                <a:spcPts val="800"/>
+              </a:spcAft>
+              <a:defRPr sz="1600">
+                <a:solidFill>
+                  <a:srgbClr val="212121"/>
+                </a:solidFill>
+                <a:latin typeface="Calibri"/>
+              </a:defRPr>
+            </a:pPr>
+            <a:r>
+              <a:t>• Dataset: ./dataset/train (70,295) · ./dataset/valid (17,572)</a:t>
             </a:r>
           </a:p>
         </p:txBody>
@@ -5676,77 +5701,6 @@
       <p:sp>
         <p:nvSpPr>
           <p:cNvPr id="4" name="TextBox 3"/>
-          <p:cNvSpPr txBox="1"/>
-          <p:nvPr/>
-        </p:nvSpPr>
-        <p:spPr>
-          <a:xfrm>
-            <a:off x="1371600" y="3108960"/>
-            <a:ext cx="9418320" cy="3108960"/>
-          </a:xfrm>
-          <a:prstGeom prst="rect">
-            <a:avLst/>
-          </a:prstGeom>
-          <a:noFill/>
-        </p:spPr>
-        <p:txBody>
-          <a:bodyPr wrap="square">
-            <a:spAutoFit/>
-          </a:bodyPr>
-          <a:lstStyle/>
-          <a:p>
-            <a:pPr>
-              <a:spcAft>
-                <a:spcPts val="800"/>
-              </a:spcAft>
-              <a:defRPr sz="1700">
-                <a:solidFill>
-                  <a:srgbClr val="212121"/>
-                </a:solidFill>
-                <a:latin typeface="Calibri"/>
-              </a:defRPr>
-            </a:pPr>
-            <a:r>
-              <a:t>• Public repo — all code, trained model, result images and docs</a:t>
-            </a:r>
-          </a:p>
-          <a:p>
-            <a:pPr>
-              <a:spcAft>
-                <a:spcPts val="800"/>
-              </a:spcAft>
-              <a:defRPr sz="1700">
-                <a:solidFill>
-                  <a:srgbClr val="212121"/>
-                </a:solidFill>
-                <a:latin typeface="Calibri"/>
-              </a:defRPr>
-            </a:pPr>
-            <a:r>
-              <a:t>• Commits trace the full workflow: setup → data → training → demo → fix</a:t>
-            </a:r>
-          </a:p>
-          <a:p>
-            <a:pPr>
-              <a:spcAft>
-                <a:spcPts val="800"/>
-              </a:spcAft>
-              <a:defRPr sz="1700">
-                <a:solidFill>
-                  <a:srgbClr val="212121"/>
-                </a:solidFill>
-                <a:latin typeface="Calibri"/>
-              </a:defRPr>
-            </a:pPr>
-            <a:r>
-              <a:t>• Clone &amp; reproduce:  git clone https://github.com/PG-Sravani/…</a:t>
-            </a:r>
-          </a:p>
-        </p:txBody>
-      </p:sp>
-      <p:sp>
-        <p:nvSpPr>
-          <p:cNvPr id="5" name="TextBox 4"/>
           <p:cNvSpPr txBox="1"/>
           <p:nvPr/>
         </p:nvSpPr>
@@ -5854,7 +5808,7 @@
               </a:defRPr>
             </a:pPr>
             <a:r>
-              <a:t>Conclusion &amp; Learning Outcomes</a:t>
+              <a:t>GitHub Repository</a:t>
             </a:r>
           </a:p>
         </p:txBody>
@@ -5867,8 +5821,8 @@
         </p:nvSpPr>
         <p:spPr>
           <a:xfrm>
-            <a:off x="822960" y="1463040"/>
-            <a:ext cx="10515600" cy="4937760"/>
+            <a:off x="914400" y="1828800"/>
+            <a:ext cx="10332720" cy="914400"/>
           </a:xfrm>
           <a:prstGeom prst="rect">
             <a:avLst/>
@@ -5881,9 +5835,45 @@
           </a:bodyPr>
           <a:lstStyle/>
           <a:p>
+            <a:pPr algn="ctr">
+              <a:defRPr sz="2800" b="1">
+                <a:solidFill>
+                  <a:srgbClr val="006699"/>
+                </a:solidFill>
+                <a:latin typeface="Calibri"/>
+              </a:defRPr>
+            </a:pPr>
+            <a:r>
+              <a:t>https://github.com/PG-Sravani/plant-leaf-disease-detection</a:t>
+            </a:r>
+          </a:p>
+        </p:txBody>
+      </p:sp>
+      <p:sp>
+        <p:nvSpPr>
+          <p:cNvPr id="4" name="TextBox 3"/>
+          <p:cNvSpPr txBox="1"/>
+          <p:nvPr/>
+        </p:nvSpPr>
+        <p:spPr>
+          <a:xfrm>
+            <a:off x="1371600" y="3108960"/>
+            <a:ext cx="9418320" cy="3108960"/>
+          </a:xfrm>
+          <a:prstGeom prst="rect">
+            <a:avLst/>
+          </a:prstGeom>
+          <a:noFill/>
+        </p:spPr>
+        <p:txBody>
+          <a:bodyPr wrap="square">
+            <a:spAutoFit/>
+          </a:bodyPr>
+          <a:lstStyle/>
+          <a:p>
             <a:pPr>
               <a:spcAft>
-                <a:spcPts val="1000"/>
+                <a:spcPts val="800"/>
               </a:spcAft>
               <a:defRPr sz="1700">
                 <a:solidFill>
@@ -5893,13 +5883,13 @@
               </a:defRPr>
             </a:pPr>
             <a:r>
-              <a:t>• Demonstrated an end-to-end deep learning pipeline for plant leaf disease detection on real Kaggle data.</a:t>
+              <a:t>• Public repo — all code, trained model, result images and docs</a:t>
             </a:r>
           </a:p>
           <a:p>
             <a:pPr>
               <a:spcAft>
-                <a:spcPts val="1000"/>
+                <a:spcPts val="800"/>
               </a:spcAft>
               <a:defRPr sz="1700">
                 <a:solidFill>
@@ -5909,13 +5899,13 @@
               </a:defRPr>
             </a:pPr>
             <a:r>
-              <a:t>• Achieved ~88% validation accuracy on a 7-class quick model using MobileNetV2 transfer learning (CPU-only environment).</a:t>
+              <a:t>• Commits trace the full workflow: setup → data → training → demo → fix</a:t>
             </a:r>
           </a:p>
           <a:p>
             <a:pPr>
               <a:spcAft>
-                <a:spcPts val="1000"/>
+                <a:spcPts val="800"/>
               </a:spcAft>
               <a:defRPr sz="1700">
                 <a:solidFill>
@@ -5925,46 +5915,14 @@
               </a:defRPr>
             </a:pPr>
             <a:r>
-              <a:t>• Full 38-class support with multiple backbones and automatic evaluation, Grad-CAM, and a deployable web UI.</a:t>
-            </a:r>
-          </a:p>
-          <a:p>
-            <a:pPr>
-              <a:spcAft>
-                <a:spcPts val="1000"/>
-              </a:spcAft>
-              <a:defRPr sz="1700">
-                <a:solidFill>
-                  <a:srgbClr val="212121"/>
-                </a:solidFill>
-                <a:latin typeface="Calibri"/>
-              </a:defRPr>
-            </a:pPr>
-            <a:r>
-              <a:t>• Learned: dataset handling, augmentation, transfer learning, callbacks, evaluation metrics, model interpretability, deployment.</a:t>
-            </a:r>
-          </a:p>
-          <a:p>
-            <a:pPr>
-              <a:spcAft>
-                <a:spcPts val="1000"/>
-              </a:spcAft>
-              <a:defRPr sz="1700">
-                <a:solidFill>
-                  <a:srgbClr val="212121"/>
-                </a:solidFill>
-                <a:latin typeface="Calibri"/>
-              </a:defRPr>
-            </a:pPr>
-            <a:r>
-              <a:t>• Real bug-fixing experience: dataset cache structure, Keras 3 API changes, and RGBA image upload handling.</a:t>
-            </a:r>
-          </a:p>
-        </p:txBody>
-      </p:sp>
-      <p:sp>
-        <p:nvSpPr>
-          <p:cNvPr id="4" name="TextBox 3"/>
+              <a:t>• Clone &amp; reproduce:  git clone https://github.com/PG-Sravani/…</a:t>
+            </a:r>
+          </a:p>
+        </p:txBody>
+      </p:sp>
+      <p:sp>
+        <p:nvSpPr>
+          <p:cNvPr id="5" name="TextBox 4"/>
           <p:cNvSpPr txBox="1"/>
           <p:nvPr/>
         </p:nvSpPr>
@@ -6072,7 +6030,7 @@
               </a:defRPr>
             </a:pPr>
             <a:r>
-              <a:t>Future Work</a:t>
+              <a:t>Conclusion &amp; Learning Outcomes</a:t>
             </a:r>
           </a:p>
         </p:txBody>
@@ -6086,7 +6044,7 @@
         <p:spPr>
           <a:xfrm>
             <a:off x="822960" y="1463040"/>
-            <a:ext cx="10515600" cy="4572000"/>
+            <a:ext cx="10515600" cy="4937760"/>
           </a:xfrm>
           <a:prstGeom prst="rect">
             <a:avLst/>
@@ -6111,7 +6069,7 @@
               </a:defRPr>
             </a:pPr>
             <a:r>
-              <a:t>• Train the full 38-class model on a GPU for production accuracy (&gt;98% typical on this dataset).</a:t>
+              <a:t>• Demonstrated an end-to-end deep learning pipeline for plant leaf disease detection on real Kaggle data.</a:t>
             </a:r>
           </a:p>
           <a:p>
@@ -6127,7 +6085,7 @@
               </a:defRPr>
             </a:pPr>
             <a:r>
-              <a:t>• Fine-tune frozen backbones by unfreezing top layers.</a:t>
+              <a:t>• Achieved ~88% validation accuracy on a 7-class quick model using MobileNetV2 transfer learning (CPU-only environment).</a:t>
             </a:r>
           </a:p>
           <a:p>
@@ -6143,7 +6101,7 @@
               </a:defRPr>
             </a:pPr>
             <a:r>
-              <a:t>• Add per-disease treatment/precaution advice in the web app.</a:t>
+              <a:t>• Full 38-class support with multiple backbones and automatic evaluation, Grad-CAM, and a deployable web UI.</a:t>
             </a:r>
           </a:p>
           <a:p>
@@ -6159,7 +6117,7 @@
               </a:defRPr>
             </a:pPr>
             <a:r>
-              <a:t>• Extend to object detection (bounding boxes) and mobile edge devices.</a:t>
+              <a:t>• Learned: dataset handling, augmentation, transfer learning, callbacks, evaluation metrics, model interpretability, deployment.</a:t>
             </a:r>
           </a:p>
           <a:p>
@@ -6175,7 +6133,7 @@
               </a:defRPr>
             </a:pPr>
             <a:r>
-              <a:t>• Add confidence-based "uncertain" flagging to flag uncertain cases for expert review.</a:t>
+              <a:t>• Real bug-fixing experience: dataset cache structure, Keras 3 API changes, and RGBA image upload handling.</a:t>
             </a:r>
           </a:p>
         </p:txBody>
@@ -6507,6 +6465,224 @@
 </file>
 
 <file path=ppt/slides/slide20.xml><?xml version="1.0" encoding="utf-8"?>
+<p:sld xmlns:a="http://schemas.openxmlformats.org/drawingml/2006/main" xmlns:p="http://schemas.openxmlformats.org/presentationml/2006/main" xmlns:r="http://schemas.openxmlformats.org/officeDocument/2006/relationships">
+  <p:cSld>
+    <p:bg>
+      <p:bgPr>
+        <a:solidFill>
+          <a:srgbClr val="FBFAF0"/>
+        </a:solidFill>
+        <a:effectLst/>
+      </p:bgPr>
+    </p:bg>
+    <p:spTree>
+      <p:nvGrpSpPr>
+        <p:cNvPr id="1" name=""/>
+        <p:cNvGrpSpPr/>
+        <p:nvPr/>
+      </p:nvGrpSpPr>
+      <p:grpSpPr/>
+      <p:sp>
+        <p:nvSpPr>
+          <p:cNvPr id="2" name="Rectangle 1"/>
+          <p:cNvSpPr/>
+          <p:nvPr/>
+        </p:nvSpPr>
+        <p:spPr>
+          <a:xfrm>
+            <a:off x="0" y="0"/>
+            <a:ext cx="12188952" cy="960120"/>
+          </a:xfrm>
+          <a:prstGeom prst="rect">
+            <a:avLst/>
+          </a:prstGeom>
+          <a:solidFill>
+            <a:srgbClr val="2E7D32"/>
+          </a:solidFill>
+          <a:ln>
+            <a:noFill/>
+          </a:ln>
+        </p:spPr>
+        <p:style>
+          <a:lnRef idx="1">
+            <a:schemeClr val="accent1"/>
+          </a:lnRef>
+          <a:fillRef idx="3">
+            <a:schemeClr val="accent1"/>
+          </a:fillRef>
+          <a:effectRef idx="2">
+            <a:schemeClr val="accent1"/>
+          </a:effectRef>
+          <a:fontRef idx="minor">
+            <a:schemeClr val="lt1"/>
+          </a:fontRef>
+        </p:style>
+        <p:txBody>
+          <a:bodyPr rtlCol="0" anchor="ctr" lIns="365760"/>
+          <a:lstStyle/>
+          <a:p>
+            <a:pPr algn="ctr">
+              <a:defRPr sz="3000" b="1">
+                <a:solidFill>
+                  <a:srgbClr val="FFFFFF"/>
+                </a:solidFill>
+                <a:latin typeface="Calibri"/>
+              </a:defRPr>
+            </a:pPr>
+            <a:r>
+              <a:t>Future Work</a:t>
+            </a:r>
+          </a:p>
+        </p:txBody>
+      </p:sp>
+      <p:sp>
+        <p:nvSpPr>
+          <p:cNvPr id="3" name="TextBox 2"/>
+          <p:cNvSpPr txBox="1"/>
+          <p:nvPr/>
+        </p:nvSpPr>
+        <p:spPr>
+          <a:xfrm>
+            <a:off x="822960" y="1463040"/>
+            <a:ext cx="10515600" cy="4572000"/>
+          </a:xfrm>
+          <a:prstGeom prst="rect">
+            <a:avLst/>
+          </a:prstGeom>
+          <a:noFill/>
+        </p:spPr>
+        <p:txBody>
+          <a:bodyPr wrap="square">
+            <a:spAutoFit/>
+          </a:bodyPr>
+          <a:lstStyle/>
+          <a:p>
+            <a:pPr>
+              <a:spcAft>
+                <a:spcPts val="1000"/>
+              </a:spcAft>
+              <a:defRPr sz="1700">
+                <a:solidFill>
+                  <a:srgbClr val="212121"/>
+                </a:solidFill>
+                <a:latin typeface="Calibri"/>
+              </a:defRPr>
+            </a:pPr>
+            <a:r>
+              <a:t>• Train the full 38-class model on a GPU for production accuracy (&gt;98% typical on this dataset).</a:t>
+            </a:r>
+          </a:p>
+          <a:p>
+            <a:pPr>
+              <a:spcAft>
+                <a:spcPts val="1000"/>
+              </a:spcAft>
+              <a:defRPr sz="1700">
+                <a:solidFill>
+                  <a:srgbClr val="212121"/>
+                </a:solidFill>
+                <a:latin typeface="Calibri"/>
+              </a:defRPr>
+            </a:pPr>
+            <a:r>
+              <a:t>• Fine-tune frozen backbones by unfreezing top layers.</a:t>
+            </a:r>
+          </a:p>
+          <a:p>
+            <a:pPr>
+              <a:spcAft>
+                <a:spcPts val="1000"/>
+              </a:spcAft>
+              <a:defRPr sz="1700">
+                <a:solidFill>
+                  <a:srgbClr val="212121"/>
+                </a:solidFill>
+                <a:latin typeface="Calibri"/>
+              </a:defRPr>
+            </a:pPr>
+            <a:r>
+              <a:t>• Add per-disease treatment/precaution advice in the web app.</a:t>
+            </a:r>
+          </a:p>
+          <a:p>
+            <a:pPr>
+              <a:spcAft>
+                <a:spcPts val="1000"/>
+              </a:spcAft>
+              <a:defRPr sz="1700">
+                <a:solidFill>
+                  <a:srgbClr val="212121"/>
+                </a:solidFill>
+                <a:latin typeface="Calibri"/>
+              </a:defRPr>
+            </a:pPr>
+            <a:r>
+              <a:t>• Extend to object detection (bounding boxes) and mobile edge devices.</a:t>
+            </a:r>
+          </a:p>
+          <a:p>
+            <a:pPr>
+              <a:spcAft>
+                <a:spcPts val="1000"/>
+              </a:spcAft>
+              <a:defRPr sz="1700">
+                <a:solidFill>
+                  <a:srgbClr val="212121"/>
+                </a:solidFill>
+                <a:latin typeface="Calibri"/>
+              </a:defRPr>
+            </a:pPr>
+            <a:r>
+              <a:t>• Add confidence-based "uncertain" flagging to flag uncertain cases for expert review.</a:t>
+            </a:r>
+          </a:p>
+        </p:txBody>
+      </p:sp>
+      <p:sp>
+        <p:nvSpPr>
+          <p:cNvPr id="4" name="TextBox 3"/>
+          <p:cNvSpPr txBox="1"/>
+          <p:nvPr/>
+        </p:nvSpPr>
+        <p:spPr>
+          <a:xfrm>
+            <a:off x="10424160" y="6400800"/>
+            <a:ext cx="1554480" cy="365760"/>
+          </a:xfrm>
+          <a:prstGeom prst="rect">
+            <a:avLst/>
+          </a:prstGeom>
+          <a:noFill/>
+        </p:spPr>
+        <p:txBody>
+          <a:bodyPr wrap="none">
+            <a:spAutoFit/>
+          </a:bodyPr>
+          <a:lstStyle/>
+          <a:p>
+            <a:pPr algn="r">
+              <a:defRPr sz="1100">
+                <a:solidFill>
+                  <a:srgbClr val="1B5E20"/>
+                </a:solidFill>
+                <a:latin typeface="Calibri"/>
+              </a:defRPr>
+            </a:pPr>
+            <a:r>
+              <a:t>IVA CIA-3 · 20</a:t>
+            </a:r>
+          </a:p>
+        </p:txBody>
+      </p:sp>
+    </p:spTree>
+  </p:cSld>
+  <p:clrMapOvr>
+    <a:masterClrMapping/>
+  </p:clrMapOvr>
+</p:sld>
+</file>
+
+<file path=ppt/slides/slide21.xml><?xml version="1.0" encoding="utf-8"?>
 <p:sld xmlns:a="http://schemas.openxmlformats.org/drawingml/2006/main" xmlns:p="http://schemas.openxmlformats.org/presentationml/2006/main" xmlns:r="http://schemas.openxmlformats.org/officeDocument/2006/relationships">
   <p:cSld>
     <p:bg>

</xml_diff>

<commit_message>
Add hybrid MobileNetV3+ViT backend from AI-Crop-Disease-Detection for the web demo
run_demo_hybrid.py + hybrid/hybrid_backend.py serve predictions from a pretrained 25-class PyTorch checkpoint (bilateral filter + vegetation indices preprocessing). Verified live via Gradio API on this machine (Potato/pepper disease ~91-100%). requirements.txt extended; PPT gains a hybrid-backend slide (now 22 slides); README documents Option D. Retrieved checkpoint + test image from github.com/Vidhi-Garg11/AI-Crop-Disease-Detection.
</commit_message>
<xml_diff>
--- a/Plant_Leaf_Disease_Detection_IVACIA3.pptx
+++ b/Plant_Leaf_Disease_Detection_IVACIA3.pptx
@@ -26,6 +26,7 @@
     <p:sldId id="274" r:id="rId25"/>
     <p:sldId id="275" r:id="rId26"/>
     <p:sldId id="276" r:id="rId27"/>
+    <p:sldId id="277" r:id="rId28"/>
   </p:sldIdLst>
   <p:sldSz cx="12191695" cy="6858000" type="screen4x3"/>
   <p:notesSz cx="6858000" cy="9144000"/>
@@ -3302,7 +3303,7 @@
               </a:defRPr>
             </a:pPr>
             <a:r>
-              <a:t>Results Summary</a:t>
+              <a:t>Training Configuration</a:t>
             </a:r>
           </a:p>
         </p:txBody>
@@ -3331,7 +3332,7 @@
           <a:p>
             <a:pPr>
               <a:spcAft>
-                <a:spcPts val="900"/>
+                <a:spcPts val="800"/>
               </a:spcAft>
               <a:defRPr sz="1700">
                 <a:solidFill>
@@ -3341,13 +3342,77 @@
               </a:defRPr>
             </a:pPr>
             <a:r>
-              <a:t>• Quick demo model (MobileNetV2, 7 classes, CPU):</a:t>
+              <a:t>• Optimizer: Adam, learning rate 1e-4 (fires REDUCED on plateau)</a:t>
+            </a:r>
+          </a:p>
+          <a:p>
+            <a:pPr>
+              <a:spcAft>
+                <a:spcPts val="800"/>
+              </a:spcAft>
+              <a:defRPr sz="1700">
+                <a:solidFill>
+                  <a:srgbClr val="212121"/>
+                </a:solidFill>
+                <a:latin typeface="Calibri"/>
+              </a:defRPr>
+            </a:pPr>
+            <a:r>
+              <a:t>• Loss: Categorical Cross-Entropy · Metric: Accuracy</a:t>
+            </a:r>
+          </a:p>
+          <a:p>
+            <a:pPr>
+              <a:spcAft>
+                <a:spcPts val="800"/>
+              </a:spcAft>
+              <a:defRPr sz="1700">
+                <a:solidFill>
+                  <a:srgbClr val="212121"/>
+                </a:solidFill>
+                <a:latin typeface="Calibri"/>
+              </a:defRPr>
+            </a:pPr>
+            <a:r>
+              <a:t>• Batch size 16–32 · Image size 224×224</a:t>
+            </a:r>
+          </a:p>
+          <a:p>
+            <a:pPr>
+              <a:spcAft>
+                <a:spcPts val="800"/>
+              </a:spcAft>
+              <a:defRPr sz="1700">
+                <a:solidFill>
+                  <a:srgbClr val="212121"/>
+                </a:solidFill>
+                <a:latin typeface="Calibri"/>
+              </a:defRPr>
+            </a:pPr>
+            <a:r>
+              <a:t>• ImageDataGenerator (tf.keras) feeds batches from disk</a:t>
+            </a:r>
+          </a:p>
+          <a:p>
+            <a:pPr>
+              <a:spcAft>
+                <a:spcPts val="800"/>
+              </a:spcAft>
+              <a:defRPr sz="1700">
+                <a:solidFill>
+                  <a:srgbClr val="212121"/>
+                </a:solidFill>
+                <a:latin typeface="Calibri"/>
+              </a:defRPr>
+            </a:pPr>
+            <a:r>
+              <a:t>• Callbacks:</a:t>
             </a:r>
           </a:p>
           <a:p>
             <a:pPr lvl="1">
               <a:spcAft>
-                <a:spcPts val="900"/>
+                <a:spcPts val="800"/>
               </a:spcAft>
               <a:defRPr sz="1500">
                 <a:solidFill>
@@ -3357,13 +3422,13 @@
               </a:defRPr>
             </a:pPr>
             <a:r>
-              <a:t>   – Validation Accuracy  ≈ 88.3%</a:t>
+              <a:t>   – EarlyStopping — stops if validation loss stops improving (patience)</a:t>
             </a:r>
           </a:p>
           <a:p>
             <a:pPr lvl="1">
               <a:spcAft>
-                <a:spcPts val="900"/>
+                <a:spcPts val="800"/>
               </a:spcAft>
               <a:defRPr sz="1500">
                 <a:solidFill>
@@ -3373,13 +3438,13 @@
               </a:defRPr>
             </a:pPr>
             <a:r>
-              <a:t>   – macro avg: precision 0.89 · recall 0.88 · F1 0.88</a:t>
+              <a:t>   – ReduceLROnPlateau — halves LR when plateaus (min 1e-7)</a:t>
             </a:r>
           </a:p>
           <a:p>
             <a:pPr lvl="1">
               <a:spcAft>
-                <a:spcPts val="900"/>
+                <a:spcPts val="800"/>
               </a:spcAft>
               <a:defRPr sz="1500">
                 <a:solidFill>
@@ -3389,13 +3454,13 @@
               </a:defRPr>
             </a:pPr>
             <a:r>
-              <a:t>   – Best per-class F1: Potato Early blight 0.97 · Tomato healthy 0.92</a:t>
+              <a:t>   – ModelCheckpoint — saves best model to models/*.keras</a:t>
             </a:r>
           </a:p>
           <a:p>
             <a:pPr>
               <a:spcAft>
-                <a:spcPts val="900"/>
+                <a:spcPts val="800"/>
               </a:spcAft>
               <a:defRPr sz="1700">
                 <a:solidFill>
@@ -3405,39 +3470,7 @@
               </a:defRPr>
             </a:pPr>
             <a:r>
-              <a:t>• Live web-demo accuracy ≈ 95% (validated via the API on real uploads)</a:t>
-            </a:r>
-          </a:p>
-          <a:p>
-            <a:pPr>
-              <a:spcAft>
-                <a:spcPts val="900"/>
-              </a:spcAft>
-              <a:defRPr sz="1700">
-                <a:solidFill>
-                  <a:srgbClr val="212121"/>
-                </a:solidFill>
-                <a:latin typeface="Calibri"/>
-              </a:defRPr>
-            </a:pPr>
-            <a:r>
-              <a:t>• Full 38-class pipeline supported (needs GPU for practical runtime)</a:t>
-            </a:r>
-          </a:p>
-          <a:p>
-            <a:pPr>
-              <a:spcAft>
-                <a:spcPts val="900"/>
-              </a:spcAft>
-              <a:defRPr sz="1700">
-                <a:solidFill>
-                  <a:srgbClr val="212121"/>
-                </a:solidFill>
-                <a:latin typeface="Calibri"/>
-              </a:defRPr>
-            </a:pPr>
-            <a:r>
-              <a:t>• Evaluations produced automatically: classification report, confusion matrix, ROC curves</a:t>
+              <a:t>• Quick demo run: 10 epochs, MobileNetV2, 840 train / 420 valid images</a:t>
             </a:r>
           </a:p>
         </p:txBody>
@@ -3552,35 +3585,146 @@
               </a:defRPr>
             </a:pPr>
             <a:r>
-              <a:t>Training &amp; Validation Curves</a:t>
-            </a:r>
-          </a:p>
-        </p:txBody>
-      </p:sp>
-      <p:pic>
-        <p:nvPicPr>
-          <p:cNvPr id="3" name="Picture 2" descr="training_curve_subset.png"/>
-          <p:cNvPicPr>
-            <a:picLocks noChangeAspect="1"/>
-          </p:cNvPicPr>
+              <a:t>Results Summary</a:t>
+            </a:r>
+          </a:p>
+        </p:txBody>
+      </p:sp>
+      <p:sp>
+        <p:nvSpPr>
+          <p:cNvPr id="3" name="TextBox 2"/>
+          <p:cNvSpPr txBox="1"/>
           <p:nvPr/>
-        </p:nvPicPr>
-        <p:blipFill>
-          <a:blip r:embed="rId2"/>
-          <a:stretch>
-            <a:fillRect/>
-          </a:stretch>
-        </p:blipFill>
+        </p:nvSpPr>
         <p:spPr>
           <a:xfrm>
-            <a:off x="2011680" y="1554480"/>
-            <a:ext cx="12545568" cy="4480560"/>
+            <a:off x="822960" y="1371600"/>
+            <a:ext cx="10972800" cy="4937760"/>
           </a:xfrm>
           <a:prstGeom prst="rect">
             <a:avLst/>
           </a:prstGeom>
+          <a:noFill/>
         </p:spPr>
-      </p:pic>
+        <p:txBody>
+          <a:bodyPr wrap="square">
+            <a:spAutoFit/>
+          </a:bodyPr>
+          <a:lstStyle/>
+          <a:p>
+            <a:pPr>
+              <a:spcAft>
+                <a:spcPts val="900"/>
+              </a:spcAft>
+              <a:defRPr sz="1700">
+                <a:solidFill>
+                  <a:srgbClr val="212121"/>
+                </a:solidFill>
+                <a:latin typeface="Calibri"/>
+              </a:defRPr>
+            </a:pPr>
+            <a:r>
+              <a:t>• Quick demo model (MobileNetV2, 7 classes, CPU):</a:t>
+            </a:r>
+          </a:p>
+          <a:p>
+            <a:pPr lvl="1">
+              <a:spcAft>
+                <a:spcPts val="900"/>
+              </a:spcAft>
+              <a:defRPr sz="1500">
+                <a:solidFill>
+                  <a:srgbClr val="212121"/>
+                </a:solidFill>
+                <a:latin typeface="Calibri"/>
+              </a:defRPr>
+            </a:pPr>
+            <a:r>
+              <a:t>   – Validation Accuracy  ≈ 88.3%</a:t>
+            </a:r>
+          </a:p>
+          <a:p>
+            <a:pPr lvl="1">
+              <a:spcAft>
+                <a:spcPts val="900"/>
+              </a:spcAft>
+              <a:defRPr sz="1500">
+                <a:solidFill>
+                  <a:srgbClr val="212121"/>
+                </a:solidFill>
+                <a:latin typeface="Calibri"/>
+              </a:defRPr>
+            </a:pPr>
+            <a:r>
+              <a:t>   – macro avg: precision 0.89 · recall 0.88 · F1 0.88</a:t>
+            </a:r>
+          </a:p>
+          <a:p>
+            <a:pPr lvl="1">
+              <a:spcAft>
+                <a:spcPts val="900"/>
+              </a:spcAft>
+              <a:defRPr sz="1500">
+                <a:solidFill>
+                  <a:srgbClr val="212121"/>
+                </a:solidFill>
+                <a:latin typeface="Calibri"/>
+              </a:defRPr>
+            </a:pPr>
+            <a:r>
+              <a:t>   – Best per-class F1: Potato Early blight 0.97 · Tomato healthy 0.92</a:t>
+            </a:r>
+          </a:p>
+          <a:p>
+            <a:pPr>
+              <a:spcAft>
+                <a:spcPts val="900"/>
+              </a:spcAft>
+              <a:defRPr sz="1700">
+                <a:solidFill>
+                  <a:srgbClr val="212121"/>
+                </a:solidFill>
+                <a:latin typeface="Calibri"/>
+              </a:defRPr>
+            </a:pPr>
+            <a:r>
+              <a:t>• Live web-demo accuracy ≈ 95% (validated via the API on real uploads)</a:t>
+            </a:r>
+          </a:p>
+          <a:p>
+            <a:pPr>
+              <a:spcAft>
+                <a:spcPts val="900"/>
+              </a:spcAft>
+              <a:defRPr sz="1700">
+                <a:solidFill>
+                  <a:srgbClr val="212121"/>
+                </a:solidFill>
+                <a:latin typeface="Calibri"/>
+              </a:defRPr>
+            </a:pPr>
+            <a:r>
+              <a:t>• Full 38-class pipeline supported (needs GPU for practical runtime)</a:t>
+            </a:r>
+          </a:p>
+          <a:p>
+            <a:pPr>
+              <a:spcAft>
+                <a:spcPts val="900"/>
+              </a:spcAft>
+              <a:defRPr sz="1700">
+                <a:solidFill>
+                  <a:srgbClr val="212121"/>
+                </a:solidFill>
+                <a:latin typeface="Calibri"/>
+              </a:defRPr>
+            </a:pPr>
+            <a:r>
+              <a:t>• Evaluations produced automatically: classification report, confusion matrix, ROC curves</a:t>
+            </a:r>
+          </a:p>
+        </p:txBody>
+      </p:sp>
       <p:sp>
         <p:nvSpPr>
           <p:cNvPr id="4" name="TextBox 3"/>
@@ -3691,14 +3835,14 @@
               </a:defRPr>
             </a:pPr>
             <a:r>
-              <a:t>Confusion Matrix (Validation)</a:t>
+              <a:t>Training &amp; Validation Curves</a:t>
             </a:r>
           </a:p>
         </p:txBody>
       </p:sp>
       <p:pic>
         <p:nvPicPr>
-          <p:cNvPr id="3" name="Picture 2" descr="confusion_matrix_subset.png"/>
+          <p:cNvPr id="3" name="Picture 2" descr="training_curve_subset.png"/>
           <p:cNvPicPr>
             <a:picLocks noChangeAspect="1"/>
           </p:cNvPicPr>
@@ -3713,7 +3857,7 @@
         <p:spPr>
           <a:xfrm>
             <a:off x="2011680" y="1554480"/>
-            <a:ext cx="5120640" cy="4480560"/>
+            <a:ext cx="12545568" cy="4480560"/>
           </a:xfrm>
           <a:prstGeom prst="rect">
             <a:avLst/>
@@ -3830,6 +3974,145 @@
               </a:defRPr>
             </a:pPr>
             <a:r>
+              <a:t>Confusion Matrix (Validation)</a:t>
+            </a:r>
+          </a:p>
+        </p:txBody>
+      </p:sp>
+      <p:pic>
+        <p:nvPicPr>
+          <p:cNvPr id="3" name="Picture 2" descr="confusion_matrix_subset.png"/>
+          <p:cNvPicPr>
+            <a:picLocks noChangeAspect="1"/>
+          </p:cNvPicPr>
+          <p:nvPr/>
+        </p:nvPicPr>
+        <p:blipFill>
+          <a:blip r:embed="rId2"/>
+          <a:stretch>
+            <a:fillRect/>
+          </a:stretch>
+        </p:blipFill>
+        <p:spPr>
+          <a:xfrm>
+            <a:off x="2011680" y="1554480"/>
+            <a:ext cx="5120640" cy="4480560"/>
+          </a:xfrm>
+          <a:prstGeom prst="rect">
+            <a:avLst/>
+          </a:prstGeom>
+        </p:spPr>
+      </p:pic>
+      <p:sp>
+        <p:nvSpPr>
+          <p:cNvPr id="4" name="TextBox 3"/>
+          <p:cNvSpPr txBox="1"/>
+          <p:nvPr/>
+        </p:nvSpPr>
+        <p:spPr>
+          <a:xfrm>
+            <a:off x="10424160" y="6400800"/>
+            <a:ext cx="1554480" cy="365760"/>
+          </a:xfrm>
+          <a:prstGeom prst="rect">
+            <a:avLst/>
+          </a:prstGeom>
+          <a:noFill/>
+        </p:spPr>
+        <p:txBody>
+          <a:bodyPr wrap="none">
+            <a:spAutoFit/>
+          </a:bodyPr>
+          <a:lstStyle/>
+          <a:p>
+            <a:pPr algn="r">
+              <a:defRPr sz="1100">
+                <a:solidFill>
+                  <a:srgbClr val="1B5E20"/>
+                </a:solidFill>
+                <a:latin typeface="Calibri"/>
+              </a:defRPr>
+            </a:pPr>
+            <a:r>
+              <a:t>IVA CIA-3 · 13</a:t>
+            </a:r>
+          </a:p>
+        </p:txBody>
+      </p:sp>
+    </p:spTree>
+  </p:cSld>
+  <p:clrMapOvr>
+    <a:masterClrMapping/>
+  </p:clrMapOvr>
+</p:sld>
+</file>
+
+<file path=ppt/slides/slide14.xml><?xml version="1.0" encoding="utf-8"?>
+<p:sld xmlns:a="http://schemas.openxmlformats.org/drawingml/2006/main" xmlns:p="http://schemas.openxmlformats.org/presentationml/2006/main" xmlns:r="http://schemas.openxmlformats.org/officeDocument/2006/relationships">
+  <p:cSld>
+    <p:bg>
+      <p:bgPr>
+        <a:solidFill>
+          <a:srgbClr val="FBFAF0"/>
+        </a:solidFill>
+        <a:effectLst/>
+      </p:bgPr>
+    </p:bg>
+    <p:spTree>
+      <p:nvGrpSpPr>
+        <p:cNvPr id="1" name=""/>
+        <p:cNvGrpSpPr/>
+        <p:nvPr/>
+      </p:nvGrpSpPr>
+      <p:grpSpPr/>
+      <p:sp>
+        <p:nvSpPr>
+          <p:cNvPr id="2" name="Rectangle 1"/>
+          <p:cNvSpPr/>
+          <p:nvPr/>
+        </p:nvSpPr>
+        <p:spPr>
+          <a:xfrm>
+            <a:off x="0" y="0"/>
+            <a:ext cx="12188952" cy="960120"/>
+          </a:xfrm>
+          <a:prstGeom prst="rect">
+            <a:avLst/>
+          </a:prstGeom>
+          <a:solidFill>
+            <a:srgbClr val="2E7D32"/>
+          </a:solidFill>
+          <a:ln>
+            <a:noFill/>
+          </a:ln>
+        </p:spPr>
+        <p:style>
+          <a:lnRef idx="1">
+            <a:schemeClr val="accent1"/>
+          </a:lnRef>
+          <a:fillRef idx="3">
+            <a:schemeClr val="accent1"/>
+          </a:fillRef>
+          <a:effectRef idx="2">
+            <a:schemeClr val="accent1"/>
+          </a:effectRef>
+          <a:fontRef idx="minor">
+            <a:schemeClr val="lt1"/>
+          </a:fontRef>
+        </p:style>
+        <p:txBody>
+          <a:bodyPr rtlCol="0" anchor="ctr" lIns="365760"/>
+          <a:lstStyle/>
+          <a:p>
+            <a:pPr algn="ctr">
+              <a:defRPr sz="3000" b="1">
+                <a:solidFill>
+                  <a:srgbClr val="FFFFFF"/>
+                </a:solidFill>
+                <a:latin typeface="Calibri"/>
+              </a:defRPr>
+            </a:pPr>
+            <a:r>
               <a:t>Model Explainability — Grad-CAM</a:t>
             </a:r>
           </a:p>
@@ -3977,7 +4260,7 @@
               </a:defRPr>
             </a:pPr>
             <a:r>
-              <a:t>IVA CIA-3 · 13</a:t>
+              <a:t>IVA CIA-3 · 14</a:t>
             </a:r>
           </a:p>
         </p:txBody>
@@ -3990,7 +4273,7 @@
 </p:sld>
 </file>
 
-<file path=ppt/slides/slide14.xml><?xml version="1.0" encoding="utf-8"?>
+<file path=ppt/slides/slide15.xml><?xml version="1.0" encoding="utf-8"?>
 <p:sld xmlns:a="http://schemas.openxmlformats.org/drawingml/2006/main" xmlns:p="http://schemas.openxmlformats.org/presentationml/2006/main" xmlns:r="http://schemas.openxmlformats.org/officeDocument/2006/relationships">
   <p:cSld>
     <p:bg>
@@ -5038,7 +5321,7 @@
               </a:defRPr>
             </a:pPr>
             <a:r>
-              <a:t>IVA CIA-3 · 14</a:t>
+              <a:t>IVA CIA-3 · 15</a:t>
             </a:r>
           </a:p>
         </p:txBody>
@@ -5051,7 +5334,7 @@
 </p:sld>
 </file>
 
-<file path=ppt/slides/slide15.xml><?xml version="1.0" encoding="utf-8"?>
+<file path=ppt/slides/slide16.xml><?xml version="1.0" encoding="utf-8"?>
 <p:sld xmlns:a="http://schemas.openxmlformats.org/drawingml/2006/main" xmlns:p="http://schemas.openxmlformats.org/presentationml/2006/main" xmlns:r="http://schemas.openxmlformats.org/officeDocument/2006/relationships">
   <p:cSld>
     <p:bg>
@@ -5172,6 +5455,22 @@
               </a:defRPr>
             </a:pPr>
             <a:r>
+              <a:t>   – run_demo_hybrid.py — second server powered by the 25-class hybrid checkpoint (same upload UI)</a:t>
+            </a:r>
+          </a:p>
+          <a:p>
+            <a:pPr lvl="1">
+              <a:spcAft>
+                <a:spcPts val="900"/>
+              </a:spcAft>
+              <a:defRPr sz="1500">
+                <a:solidFill>
+                  <a:srgbClr val="212121"/>
+                </a:solidFill>
+                <a:latin typeface="Calibri"/>
+              </a:defRPr>
+            </a:pPr>
+            <a:r>
               <a:t>   – Browser UI at http://127.0.0.1:7860</a:t>
             </a:r>
           </a:p>
@@ -5272,7 +5571,7 @@
               </a:defRPr>
             </a:pPr>
             <a:r>
-              <a:t>IVA CIA-3 · 15</a:t>
+              <a:t>IVA CIA-3 · 16</a:t>
             </a:r>
           </a:p>
         </p:txBody>
@@ -5285,7 +5584,7 @@
 </p:sld>
 </file>
 
-<file path=ppt/slides/slide16.xml><?xml version="1.0" encoding="utf-8"?>
+<file path=ppt/slides/slide17.xml><?xml version="1.0" encoding="utf-8"?>
 <p:sld xmlns:a="http://schemas.openxmlformats.org/drawingml/2006/main" xmlns:p="http://schemas.openxmlformats.org/presentationml/2006/main" xmlns:r="http://schemas.openxmlformats.org/officeDocument/2006/relationships">
   <p:cSld>
     <p:bg>
@@ -5447,7 +5746,7 @@
               </a:defRPr>
             </a:pPr>
             <a:r>
-              <a:t>IVA CIA-3 · 16</a:t>
+              <a:t>IVA CIA-3 · 17</a:t>
             </a:r>
           </a:p>
         </p:txBody>
@@ -5460,7 +5759,7 @@
 </p:sld>
 </file>
 
-<file path=ppt/slides/slide17.xml><?xml version="1.0" encoding="utf-8"?>
+<file path=ppt/slides/slide18.xml><?xml version="1.0" encoding="utf-8"?>
 <p:sld xmlns:a="http://schemas.openxmlformats.org/drawingml/2006/main" xmlns:p="http://schemas.openxmlformats.org/presentationml/2006/main" xmlns:r="http://schemas.openxmlformats.org/officeDocument/2006/relationships">
   <p:cSld>
     <p:bg>
@@ -5597,6 +5896,22 @@
               </a:defRPr>
             </a:pPr>
             <a:r>
+              <a:t>• hybrid/hybrid_backend.py + hybrid_model_best.pth — MobileNetV3+ViT backend (PyTorch)</a:t>
+            </a:r>
+          </a:p>
+          <a:p>
+            <a:pPr>
+              <a:spcAft>
+                <a:spcPts val="800"/>
+              </a:spcAft>
+              <a:defRPr sz="1600">
+                <a:solidFill>
+                  <a:srgbClr val="212121"/>
+                </a:solidFill>
+                <a:latin typeface="Calibri"/>
+              </a:defRPr>
+            </a:pPr>
+            <a:r>
               <a:t>• download_dataset.py — automatic Kaggle download</a:t>
             </a:r>
           </a:p>
@@ -5729,7 +6044,7 @@
               </a:defRPr>
             </a:pPr>
             <a:r>
-              <a:t>IVA CIA-3 · 17</a:t>
+              <a:t>IVA CIA-3 · 18</a:t>
             </a:r>
           </a:p>
         </p:txBody>
@@ -5742,7 +6057,7 @@
 </p:sld>
 </file>
 
-<file path=ppt/slides/slide18.xml><?xml version="1.0" encoding="utf-8"?>
+<file path=ppt/slides/slide19.xml><?xml version="1.0" encoding="utf-8"?>
 <p:sld xmlns:a="http://schemas.openxmlformats.org/drawingml/2006/main" xmlns:p="http://schemas.openxmlformats.org/presentationml/2006/main" xmlns:r="http://schemas.openxmlformats.org/officeDocument/2006/relationships">
   <p:cSld>
     <p:bg>
@@ -5951,7 +6266,7 @@
               </a:defRPr>
             </a:pPr>
             <a:r>
-              <a:t>IVA CIA-3 · 18</a:t>
+              <a:t>IVA CIA-3 · 19</a:t>
             </a:r>
           </a:p>
         </p:txBody>
@@ -5964,7 +6279,7 @@
 </p:sld>
 </file>
 
-<file path=ppt/slides/slide19.xml><?xml version="1.0" encoding="utf-8"?>
+<file path=ppt/slides/slide2.xml><?xml version="1.0" encoding="utf-8"?>
 <p:sld xmlns:a="http://schemas.openxmlformats.org/drawingml/2006/main" xmlns:p="http://schemas.openxmlformats.org/presentationml/2006/main" xmlns:r="http://schemas.openxmlformats.org/officeDocument/2006/relationships">
   <p:cSld>
     <p:bg>
@@ -6030,7 +6345,7 @@
               </a:defRPr>
             </a:pPr>
             <a:r>
-              <a:t>Conclusion &amp; Learning Outcomes</a:t>
+              <a:t>Agenda</a:t>
             </a:r>
           </a:p>
         </p:txBody>
@@ -6044,7 +6359,7 @@
         <p:spPr>
           <a:xfrm>
             <a:off x="822960" y="1463040"/>
-            <a:ext cx="10515600" cy="4937760"/>
+            <a:ext cx="10515600" cy="4754880"/>
           </a:xfrm>
           <a:prstGeom prst="rect">
             <a:avLst/>
@@ -6061,15 +6376,15 @@
               <a:spcAft>
                 <a:spcPts val="1000"/>
               </a:spcAft>
-              <a:defRPr sz="1700">
-                <a:solidFill>
-                  <a:srgbClr val="212121"/>
-                </a:solidFill>
-                <a:latin typeface="Calibri"/>
-              </a:defRPr>
-            </a:pPr>
-            <a:r>
-              <a:t>• Demonstrated an end-to-end deep learning pipeline for plant leaf disease detection on real Kaggle data.</a:t>
+              <a:defRPr sz="1800">
+                <a:solidFill>
+                  <a:srgbClr val="212121"/>
+                </a:solidFill>
+                <a:latin typeface="Calibri"/>
+              </a:defRPr>
+            </a:pPr>
+            <a:r>
+              <a:t>• Objective &amp; problem statement</a:t>
             </a:r>
           </a:p>
           <a:p>
@@ -6077,15 +6392,15 @@
               <a:spcAft>
                 <a:spcPts val="1000"/>
               </a:spcAft>
-              <a:defRPr sz="1700">
-                <a:solidFill>
-                  <a:srgbClr val="212121"/>
-                </a:solidFill>
-                <a:latin typeface="Calibri"/>
-              </a:defRPr>
-            </a:pPr>
-            <a:r>
-              <a:t>• Achieved ~88% validation accuracy on a 7-class quick model using MobileNetV2 transfer learning (CPU-only environment).</a:t>
+              <a:defRPr sz="1800">
+                <a:solidFill>
+                  <a:srgbClr val="212121"/>
+                </a:solidFill>
+                <a:latin typeface="Calibri"/>
+              </a:defRPr>
+            </a:pPr>
+            <a:r>
+              <a:t>• Dataset used (Kaggle – New Plant Diseases Dataset)</a:t>
             </a:r>
           </a:p>
           <a:p>
@@ -6093,15 +6408,15 @@
               <a:spcAft>
                 <a:spcPts val="1000"/>
               </a:spcAft>
-              <a:defRPr sz="1700">
-                <a:solidFill>
-                  <a:srgbClr val="212121"/>
-                </a:solidFill>
-                <a:latin typeface="Calibri"/>
-              </a:defRPr>
-            </a:pPr>
-            <a:r>
-              <a:t>• Full 38-class support with multiple backbones and automatic evaluation, Grad-CAM, and a deployable web UI.</a:t>
+              <a:defRPr sz="1800">
+                <a:solidFill>
+                  <a:srgbClr val="212121"/>
+                </a:solidFill>
+                <a:latin typeface="Calibri"/>
+              </a:defRPr>
+            </a:pPr>
+            <a:r>
+              <a:t>• Implementation pipeline: Input → Preprocessing → Model → Output</a:t>
             </a:r>
           </a:p>
           <a:p>
@@ -6109,15 +6424,15 @@
               <a:spcAft>
                 <a:spcPts val="1000"/>
               </a:spcAft>
-              <a:defRPr sz="1700">
-                <a:solidFill>
-                  <a:srgbClr val="212121"/>
-                </a:solidFill>
-                <a:latin typeface="Calibri"/>
-              </a:defRPr>
-            </a:pPr>
-            <a:r>
-              <a:t>• Learned: dataset handling, augmentation, transfer learning, callbacks, evaluation metrics, model interpretability, deployment.</a:t>
+              <a:defRPr sz="1800">
+                <a:solidFill>
+                  <a:srgbClr val="212121"/>
+                </a:solidFill>
+                <a:latin typeface="Calibri"/>
+              </a:defRPr>
+            </a:pPr>
+            <a:r>
+              <a:t>• Deep learning architectures (Custom CNN + Transfer Learning)</a:t>
             </a:r>
           </a:p>
           <a:p>
@@ -6125,15 +6440,79 @@
               <a:spcAft>
                 <a:spcPts val="1000"/>
               </a:spcAft>
-              <a:defRPr sz="1700">
-                <a:solidFill>
-                  <a:srgbClr val="212121"/>
-                </a:solidFill>
-                <a:latin typeface="Calibri"/>
-              </a:defRPr>
-            </a:pPr>
-            <a:r>
-              <a:t>• Real bug-fixing experience: dataset cache structure, Keras 3 API changes, and RGBA image upload handling.</a:t>
+              <a:defRPr sz="1800">
+                <a:solidFill>
+                  <a:srgbClr val="212121"/>
+                </a:solidFill>
+                <a:latin typeface="Calibri"/>
+              </a:defRPr>
+            </a:pPr>
+            <a:r>
+              <a:t>• Training configuration &amp; callbacks</a:t>
+            </a:r>
+          </a:p>
+          <a:p>
+            <a:pPr>
+              <a:spcAft>
+                <a:spcPts val="1000"/>
+              </a:spcAft>
+              <a:defRPr sz="1800">
+                <a:solidFill>
+                  <a:srgbClr val="212121"/>
+                </a:solidFill>
+                <a:latin typeface="Calibri"/>
+              </a:defRPr>
+            </a:pPr>
+            <a:r>
+              <a:t>• Results: accuracy, training curves, confusion matrix</a:t>
+            </a:r>
+          </a:p>
+          <a:p>
+            <a:pPr>
+              <a:spcAft>
+                <a:spcPts val="1000"/>
+              </a:spcAft>
+              <a:defRPr sz="1800">
+                <a:solidFill>
+                  <a:srgbClr val="212121"/>
+                </a:solidFill>
+                <a:latin typeface="Calibri"/>
+              </a:defRPr>
+            </a:pPr>
+            <a:r>
+              <a:t>• Explainability with Grad-CAM</a:t>
+            </a:r>
+          </a:p>
+          <a:p>
+            <a:pPr>
+              <a:spcAft>
+                <a:spcPts val="1000"/>
+              </a:spcAft>
+              <a:defRPr sz="1800">
+                <a:solidFill>
+                  <a:srgbClr val="212121"/>
+                </a:solidFill>
+                <a:latin typeface="Calibri"/>
+              </a:defRPr>
+            </a:pPr>
+            <a:r>
+              <a:t>• Web application (Gradio) for real-world prediction</a:t>
+            </a:r>
+          </a:p>
+          <a:p>
+            <a:pPr>
+              <a:spcAft>
+                <a:spcPts val="1000"/>
+              </a:spcAft>
+              <a:defRPr sz="1800">
+                <a:solidFill>
+                  <a:srgbClr val="212121"/>
+                </a:solidFill>
+                <a:latin typeface="Calibri"/>
+              </a:defRPr>
+            </a:pPr>
+            <a:r>
+              <a:t>• Project files, GitHub repository &amp; conclusions</a:t>
             </a:r>
           </a:p>
         </p:txBody>
@@ -6169,7 +6548,7 @@
               </a:defRPr>
             </a:pPr>
             <a:r>
-              <a:t>IVA CIA-3 · 19</a:t>
+              <a:t>IVA CIA-3 · 2</a:t>
             </a:r>
           </a:p>
         </p:txBody>
@@ -6182,7 +6561,7 @@
 </p:sld>
 </file>
 
-<file path=ppt/slides/slide2.xml><?xml version="1.0" encoding="utf-8"?>
+<file path=ppt/slides/slide20.xml><?xml version="1.0" encoding="utf-8"?>
 <p:sld xmlns:a="http://schemas.openxmlformats.org/drawingml/2006/main" xmlns:p="http://schemas.openxmlformats.org/presentationml/2006/main" xmlns:r="http://schemas.openxmlformats.org/officeDocument/2006/relationships">
   <p:cSld>
     <p:bg>
@@ -6248,7 +6627,7 @@
               </a:defRPr>
             </a:pPr>
             <a:r>
-              <a:t>Agenda</a:t>
+              <a:t>Conclusion &amp; Learning Outcomes</a:t>
             </a:r>
           </a:p>
         </p:txBody>
@@ -6262,7 +6641,7 @@
         <p:spPr>
           <a:xfrm>
             <a:off x="822960" y="1463040"/>
-            <a:ext cx="10515600" cy="4754880"/>
+            <a:ext cx="10515600" cy="4937760"/>
           </a:xfrm>
           <a:prstGeom prst="rect">
             <a:avLst/>
@@ -6279,15 +6658,15 @@
               <a:spcAft>
                 <a:spcPts val="1000"/>
               </a:spcAft>
-              <a:defRPr sz="1800">
-                <a:solidFill>
-                  <a:srgbClr val="212121"/>
-                </a:solidFill>
-                <a:latin typeface="Calibri"/>
-              </a:defRPr>
-            </a:pPr>
-            <a:r>
-              <a:t>• Objective &amp; problem statement</a:t>
+              <a:defRPr sz="1700">
+                <a:solidFill>
+                  <a:srgbClr val="212121"/>
+                </a:solidFill>
+                <a:latin typeface="Calibri"/>
+              </a:defRPr>
+            </a:pPr>
+            <a:r>
+              <a:t>• Demonstrated an end-to-end deep learning pipeline for plant leaf disease detection on real Kaggle data.</a:t>
             </a:r>
           </a:p>
           <a:p>
@@ -6295,15 +6674,15 @@
               <a:spcAft>
                 <a:spcPts val="1000"/>
               </a:spcAft>
-              <a:defRPr sz="1800">
-                <a:solidFill>
-                  <a:srgbClr val="212121"/>
-                </a:solidFill>
-                <a:latin typeface="Calibri"/>
-              </a:defRPr>
-            </a:pPr>
-            <a:r>
-              <a:t>• Dataset used (Kaggle – New Plant Diseases Dataset)</a:t>
+              <a:defRPr sz="1700">
+                <a:solidFill>
+                  <a:srgbClr val="212121"/>
+                </a:solidFill>
+                <a:latin typeface="Calibri"/>
+              </a:defRPr>
+            </a:pPr>
+            <a:r>
+              <a:t>• Achieved ~88% validation accuracy on a 7-class quick model using MobileNetV2 transfer learning (CPU-only environment).</a:t>
             </a:r>
           </a:p>
           <a:p>
@@ -6311,15 +6690,15 @@
               <a:spcAft>
                 <a:spcPts val="1000"/>
               </a:spcAft>
-              <a:defRPr sz="1800">
-                <a:solidFill>
-                  <a:srgbClr val="212121"/>
-                </a:solidFill>
-                <a:latin typeface="Calibri"/>
-              </a:defRPr>
-            </a:pPr>
-            <a:r>
-              <a:t>• Implementation pipeline: Input → Preprocessing → Model → Output</a:t>
+              <a:defRPr sz="1700">
+                <a:solidFill>
+                  <a:srgbClr val="212121"/>
+                </a:solidFill>
+                <a:latin typeface="Calibri"/>
+              </a:defRPr>
+            </a:pPr>
+            <a:r>
+              <a:t>• Full 38-class support with multiple backbones and automatic evaluation, Grad-CAM, and a deployable web UI.</a:t>
             </a:r>
           </a:p>
           <a:p>
@@ -6327,15 +6706,15 @@
               <a:spcAft>
                 <a:spcPts val="1000"/>
               </a:spcAft>
-              <a:defRPr sz="1800">
-                <a:solidFill>
-                  <a:srgbClr val="212121"/>
-                </a:solidFill>
-                <a:latin typeface="Calibri"/>
-              </a:defRPr>
-            </a:pPr>
-            <a:r>
-              <a:t>• Deep learning architectures (Custom CNN + Transfer Learning)</a:t>
+              <a:defRPr sz="1700">
+                <a:solidFill>
+                  <a:srgbClr val="212121"/>
+                </a:solidFill>
+                <a:latin typeface="Calibri"/>
+              </a:defRPr>
+            </a:pPr>
+            <a:r>
+              <a:t>• Learned: dataset handling, augmentation, transfer learning, callbacks, evaluation metrics, model interpretability, deployment.</a:t>
             </a:r>
           </a:p>
           <a:p>
@@ -6343,79 +6722,15 @@
               <a:spcAft>
                 <a:spcPts val="1000"/>
               </a:spcAft>
-              <a:defRPr sz="1800">
-                <a:solidFill>
-                  <a:srgbClr val="212121"/>
-                </a:solidFill>
-                <a:latin typeface="Calibri"/>
-              </a:defRPr>
-            </a:pPr>
-            <a:r>
-              <a:t>• Training configuration &amp; callbacks</a:t>
-            </a:r>
-          </a:p>
-          <a:p>
-            <a:pPr>
-              <a:spcAft>
-                <a:spcPts val="1000"/>
-              </a:spcAft>
-              <a:defRPr sz="1800">
-                <a:solidFill>
-                  <a:srgbClr val="212121"/>
-                </a:solidFill>
-                <a:latin typeface="Calibri"/>
-              </a:defRPr>
-            </a:pPr>
-            <a:r>
-              <a:t>• Results: accuracy, training curves, confusion matrix</a:t>
-            </a:r>
-          </a:p>
-          <a:p>
-            <a:pPr>
-              <a:spcAft>
-                <a:spcPts val="1000"/>
-              </a:spcAft>
-              <a:defRPr sz="1800">
-                <a:solidFill>
-                  <a:srgbClr val="212121"/>
-                </a:solidFill>
-                <a:latin typeface="Calibri"/>
-              </a:defRPr>
-            </a:pPr>
-            <a:r>
-              <a:t>• Explainability with Grad-CAM</a:t>
-            </a:r>
-          </a:p>
-          <a:p>
-            <a:pPr>
-              <a:spcAft>
-                <a:spcPts val="1000"/>
-              </a:spcAft>
-              <a:defRPr sz="1800">
-                <a:solidFill>
-                  <a:srgbClr val="212121"/>
-                </a:solidFill>
-                <a:latin typeface="Calibri"/>
-              </a:defRPr>
-            </a:pPr>
-            <a:r>
-              <a:t>• Web application (Gradio) for real-world prediction</a:t>
-            </a:r>
-          </a:p>
-          <a:p>
-            <a:pPr>
-              <a:spcAft>
-                <a:spcPts val="1000"/>
-              </a:spcAft>
-              <a:defRPr sz="1800">
-                <a:solidFill>
-                  <a:srgbClr val="212121"/>
-                </a:solidFill>
-                <a:latin typeface="Calibri"/>
-              </a:defRPr>
-            </a:pPr>
-            <a:r>
-              <a:t>• Project files, GitHub repository &amp; conclusions</a:t>
+              <a:defRPr sz="1700">
+                <a:solidFill>
+                  <a:srgbClr val="212121"/>
+                </a:solidFill>
+                <a:latin typeface="Calibri"/>
+              </a:defRPr>
+            </a:pPr>
+            <a:r>
+              <a:t>• Real bug-fixing experience: dataset cache structure, Keras 3 API changes, and RGBA image upload handling.</a:t>
             </a:r>
           </a:p>
         </p:txBody>
@@ -6451,7 +6766,7 @@
               </a:defRPr>
             </a:pPr>
             <a:r>
-              <a:t>IVA CIA-3 · 2</a:t>
+              <a:t>IVA CIA-3 · 20</a:t>
             </a:r>
           </a:p>
         </p:txBody>
@@ -6464,7 +6779,7 @@
 </p:sld>
 </file>
 
-<file path=ppt/slides/slide20.xml><?xml version="1.0" encoding="utf-8"?>
+<file path=ppt/slides/slide21.xml><?xml version="1.0" encoding="utf-8"?>
 <p:sld xmlns:a="http://schemas.openxmlformats.org/drawingml/2006/main" xmlns:p="http://schemas.openxmlformats.org/presentationml/2006/main" xmlns:r="http://schemas.openxmlformats.org/officeDocument/2006/relationships">
   <p:cSld>
     <p:bg>
@@ -6669,7 +6984,7 @@
               </a:defRPr>
             </a:pPr>
             <a:r>
-              <a:t>IVA CIA-3 · 20</a:t>
+              <a:t>IVA CIA-3 · 21</a:t>
             </a:r>
           </a:p>
         </p:txBody>
@@ -6682,7 +6997,7 @@
 </p:sld>
 </file>
 
-<file path=ppt/slides/slide21.xml><?xml version="1.0" encoding="utf-8"?>
+<file path=ppt/slides/slide22.xml><?xml version="1.0" encoding="utf-8"?>
 <p:sld xmlns:a="http://schemas.openxmlformats.org/drawingml/2006/main" xmlns:p="http://schemas.openxmlformats.org/presentationml/2006/main" xmlns:r="http://schemas.openxmlformats.org/officeDocument/2006/relationships">
   <p:cSld>
     <p:bg>
@@ -8366,7 +8681,7 @@
               </a:defRPr>
             </a:pPr>
             <a:r>
-              <a:t>Training Configuration</a:t>
+              <a:t>Hybrid Backend — MobileNetV3 + Vision Transformer</a:t>
             </a:r>
           </a:p>
         </p:txBody>
@@ -8380,7 +8695,7 @@
         <p:spPr>
           <a:xfrm>
             <a:off x="822960" y="1371600"/>
-            <a:ext cx="10972800" cy="4937760"/>
+            <a:ext cx="10972800" cy="3566160"/>
           </a:xfrm>
           <a:prstGeom prst="rect">
             <a:avLst/>
@@ -8405,7 +8720,71 @@
               </a:defRPr>
             </a:pPr>
             <a:r>
-              <a:t>• Optimizer: Adam, learning rate 1e-4 (fires REDUCED on plateau)</a:t>
+              <a:t>• Integrated as the web-app prediction engine (PyTorch, CPU):</a:t>
+            </a:r>
+          </a:p>
+          <a:p>
+            <a:pPr lvl="1">
+              <a:spcAft>
+                <a:spcPts val="800"/>
+              </a:spcAft>
+              <a:defRPr sz="1500">
+                <a:solidFill>
+                  <a:srgbClr val="212121"/>
+                </a:solidFill>
+                <a:latin typeface="Calibri"/>
+              </a:defRPr>
+            </a:pPr>
+            <a:r>
+              <a:t>   – MobileNetV3-Large CNN backbone → 1×1 projection (embed 160)</a:t>
+            </a:r>
+          </a:p>
+          <a:p>
+            <a:pPr lvl="1">
+              <a:spcAft>
+                <a:spcPts val="800"/>
+              </a:spcAft>
+              <a:defRPr sz="1500">
+                <a:solidFill>
+                  <a:srgbClr val="212121"/>
+                </a:solidFill>
+                <a:latin typeface="Calibri"/>
+              </a:defRPr>
+            </a:pPr>
+            <a:r>
+              <a:t>   – 49 spatial tokens + learned positional embedding</a:t>
+            </a:r>
+          </a:p>
+          <a:p>
+            <a:pPr lvl="1">
+              <a:spcAft>
+                <a:spcPts val="800"/>
+              </a:spcAft>
+              <a:defRPr sz="1500">
+                <a:solidFill>
+                  <a:srgbClr val="212121"/>
+                </a:solidFill>
+                <a:latin typeface="Calibri"/>
+              </a:defRPr>
+            </a:pPr>
+            <a:r>
+              <a:t>   – 2 Transformer encoder blocks (self-attention + MLP)</a:t>
+            </a:r>
+          </a:p>
+          <a:p>
+            <a:pPr lvl="1">
+              <a:spcAft>
+                <a:spcPts val="800"/>
+              </a:spcAft>
+              <a:defRPr sz="1500">
+                <a:solidFill>
+                  <a:srgbClr val="212121"/>
+                </a:solidFill>
+                <a:latin typeface="Calibri"/>
+              </a:defRPr>
+            </a:pPr>
+            <a:r>
+              <a:t>   – LayerNorm → mean-pool → classification head (25 PlantVillage classes)</a:t>
             </a:r>
           </a:p>
           <a:p>
@@ -8421,7 +8800,7 @@
               </a:defRPr>
             </a:pPr>
             <a:r>
-              <a:t>• Loss: Categorical Cross-Entropy · Metric: Accuracy</a:t>
+              <a:t>• Pretrained checkpoint: 3.7M params, 45 MB, 25 classes</a:t>
             </a:r>
           </a:p>
           <a:p>
@@ -8437,103 +8816,7 @@
               </a:defRPr>
             </a:pPr>
             <a:r>
-              <a:t>• Batch size 16–32 · Image size 224×224</a:t>
-            </a:r>
-          </a:p>
-          <a:p>
-            <a:pPr>
-              <a:spcAft>
-                <a:spcPts val="800"/>
-              </a:spcAft>
-              <a:defRPr sz="1700">
-                <a:solidFill>
-                  <a:srgbClr val="212121"/>
-                </a:solidFill>
-                <a:latin typeface="Calibri"/>
-              </a:defRPr>
-            </a:pPr>
-            <a:r>
-              <a:t>• ImageDataGenerator (tf.keras) feeds batches from disk</a:t>
-            </a:r>
-          </a:p>
-          <a:p>
-            <a:pPr>
-              <a:spcAft>
-                <a:spcPts val="800"/>
-              </a:spcAft>
-              <a:defRPr sz="1700">
-                <a:solidFill>
-                  <a:srgbClr val="212121"/>
-                </a:solidFill>
-                <a:latin typeface="Calibri"/>
-              </a:defRPr>
-            </a:pPr>
-            <a:r>
-              <a:t>• Callbacks:</a:t>
-            </a:r>
-          </a:p>
-          <a:p>
-            <a:pPr lvl="1">
-              <a:spcAft>
-                <a:spcPts val="800"/>
-              </a:spcAft>
-              <a:defRPr sz="1500">
-                <a:solidFill>
-                  <a:srgbClr val="212121"/>
-                </a:solidFill>
-                <a:latin typeface="Calibri"/>
-              </a:defRPr>
-            </a:pPr>
-            <a:r>
-              <a:t>   – EarlyStopping — stops if validation loss stops improving (patience)</a:t>
-            </a:r>
-          </a:p>
-          <a:p>
-            <a:pPr lvl="1">
-              <a:spcAft>
-                <a:spcPts val="800"/>
-              </a:spcAft>
-              <a:defRPr sz="1500">
-                <a:solidFill>
-                  <a:srgbClr val="212121"/>
-                </a:solidFill>
-                <a:latin typeface="Calibri"/>
-              </a:defRPr>
-            </a:pPr>
-            <a:r>
-              <a:t>   – ReduceLROnPlateau — halves LR when plateaus (min 1e-7)</a:t>
-            </a:r>
-          </a:p>
-          <a:p>
-            <a:pPr lvl="1">
-              <a:spcAft>
-                <a:spcPts val="800"/>
-              </a:spcAft>
-              <a:defRPr sz="1500">
-                <a:solidFill>
-                  <a:srgbClr val="212121"/>
-                </a:solidFill>
-                <a:latin typeface="Calibri"/>
-              </a:defRPr>
-            </a:pPr>
-            <a:r>
-              <a:t>   – ModelCheckpoint — saves best model to models/*.keras</a:t>
-            </a:r>
-          </a:p>
-          <a:p>
-            <a:pPr>
-              <a:spcAft>
-                <a:spcPts val="800"/>
-              </a:spcAft>
-              <a:defRPr sz="1700">
-                <a:solidFill>
-                  <a:srgbClr val="212121"/>
-                </a:solidFill>
-                <a:latin typeface="Calibri"/>
-              </a:defRPr>
-            </a:pPr>
-            <a:r>
-              <a:t>• Quick demo run: 10 epochs, MobileNetV2, 840 train / 420 valid images</a:t>
+              <a:t>• Preprocessing: bilateral filter → vegetation indices (ExG/ExR) → ImageNet normalization</a:t>
             </a:r>
           </a:p>
         </p:txBody>
@@ -8541,6 +8824,42 @@
       <p:sp>
         <p:nvSpPr>
           <p:cNvPr id="4" name="TextBox 3"/>
+          <p:cNvSpPr txBox="1"/>
+          <p:nvPr/>
+        </p:nvSpPr>
+        <p:spPr>
+          <a:xfrm>
+            <a:off x="822960" y="5120640"/>
+            <a:ext cx="10515600" cy="1188720"/>
+          </a:xfrm>
+          <a:prstGeom prst="rect">
+            <a:avLst/>
+          </a:prstGeom>
+          <a:noFill/>
+        </p:spPr>
+        <p:txBody>
+          <a:bodyPr wrap="square">
+            <a:spAutoFit/>
+          </a:bodyPr>
+          <a:lstStyle/>
+          <a:p>
+            <a:pPr algn="ctr">
+              <a:defRPr sz="1300" b="0">
+                <a:solidFill>
+                  <a:srgbClr val="212121"/>
+                </a:solidFill>
+                <a:latin typeface="Calibri"/>
+              </a:defRPr>
+            </a:pPr>
+            <a:r>
+              <a:t>Verified here on CPU: Potato &amp; pepper disease images detected at 90–100%, healthy-vs-healthy between crops remains difficult (e.g. potato healthy ~49%). Source: github.com/Vidhi-Garg11/AI-Crop-Disease-Detection</a:t>
+            </a:r>
+          </a:p>
+        </p:txBody>
+      </p:sp>
+      <p:sp>
+        <p:nvSpPr>
+          <p:cNvPr id="5" name="TextBox 4"/>
           <p:cNvSpPr txBox="1"/>
           <p:nvPr/>
         </p:nvSpPr>

</xml_diff>